<commit_message>
check commit with new diapo in pptx
</commit_message>
<xml_diff>
--- a/CP_project_midterm_presentation.pptx
+++ b/CP_project_midterm_presentation.pptx
@@ -5,12 +5,13 @@
     <p:sldMasterId id="2147483648" r:id="rId1"/>
   </p:sldMasterIdLst>
   <p:notesMasterIdLst>
-    <p:notesMasterId r:id="rId7"/>
+    <p:notesMasterId r:id="rId8"/>
   </p:notesMasterIdLst>
   <p:sldIdLst>
     <p:sldId id="256" r:id="rId4"/>
     <p:sldId id="257" r:id="rId5"/>
     <p:sldId id="258" r:id="rId6"/>
+    <p:sldId id="259" r:id="rId7"/>
   </p:sldIdLst>
   <p:sldSz cx="12192000" cy="6858000"/>
   <p:notesSz cx="6858000" cy="9144000"/>
@@ -728,6 +729,88 @@
               <a:defRPr/>
             </a:pPr>
             <a:fld id="{4E8DC1ED-EF3A-9096-071B-094DF0595504}" type="slidenum">
+              <a:rPr/>
+              <a:t/>
+            </a:fld>
+            <a:endParaRPr/>
+          </a:p>
+        </p:txBody>
+      </p:sp>
+    </p:spTree>
+  </p:cSld>
+</p:notes>
+</file>
+
+<file path=ppt/notesSlides/notesSlide4.xml><?xml version="1.0" encoding="utf-8"?>
+<p:notes xmlns:a="http://schemas.openxmlformats.org/drawingml/2006/main" xmlns:r="http://schemas.openxmlformats.org/officeDocument/2006/relationships" xmlns:p="http://schemas.openxmlformats.org/presentationml/2006/main" xmlns:m="http://schemas.openxmlformats.org/officeDocument/2006/math" xmlns:w="http://schemas.openxmlformats.org/wordprocessingml/2006/main">
+  <p:cSld name="">
+    <p:spTree>
+      <p:nvGrpSpPr>
+        <p:cNvPr id="1" name=""/>
+        <p:cNvGrpSpPr/>
+        <p:nvPr/>
+      </p:nvGrpSpPr>
+      <p:grpSpPr bwMode="auto">
+        <a:xfrm>
+          <a:off x="0" y="0"/>
+          <a:ext cx="0" cy="0"/>
+          <a:chOff x="0" y="0"/>
+          <a:chExt cx="0" cy="0"/>
+        </a:xfrm>
+      </p:grpSpPr>
+      <p:sp>
+        <p:nvSpPr>
+          <p:cNvPr id="2" name="Slide Image Placeholder 1"/>
+          <p:cNvSpPr>
+            <a:spLocks noChangeAspect="1" noGrp="1" noRot="1"/>
+          </p:cNvSpPr>
+          <p:nvPr>
+            <p:ph type="sldImg"/>
+          </p:nvPr>
+        </p:nvSpPr>
+        <p:spPr bwMode="auto"/>
+      </p:sp>
+      <p:sp>
+        <p:nvSpPr>
+          <p:cNvPr id="3" name="Notes Placeholder 2"/>
+          <p:cNvSpPr>
+            <a:spLocks noGrp="1"/>
+          </p:cNvSpPr>
+          <p:nvPr>
+            <p:ph type="body" idx="1"/>
+          </p:nvPr>
+        </p:nvSpPr>
+        <p:spPr bwMode="auto"/>
+        <p:txBody>
+          <a:bodyPr/>
+          <a:lstStyle/>
+          <a:p>
+            <a:pPr>
+              <a:defRPr/>
+            </a:pPr>
+            <a:endParaRPr/>
+          </a:p>
+        </p:txBody>
+      </p:sp>
+      <p:sp>
+        <p:nvSpPr>
+          <p:cNvPr id="4" name="Slide Number Placeholder 3"/>
+          <p:cNvSpPr>
+            <a:spLocks noGrp="1"/>
+          </p:cNvSpPr>
+          <p:nvPr>
+            <p:ph type="sldNum" sz="quarter" idx="10"/>
+          </p:nvPr>
+        </p:nvSpPr>
+        <p:spPr bwMode="auto"/>
+        <p:txBody>
+          <a:bodyPr/>
+          <a:lstStyle/>
+          <a:p>
+            <a:pPr>
+              <a:defRPr/>
+            </a:pPr>
+            <a:fld id="{0C6F982C-9ABE-BEB3-A98B-6AA777F6DAAD}" type="slidenum">
               <a:rPr/>
               <a:t/>
             </a:fld>
@@ -4024,7 +4107,7 @@
         </p:nvSpPr>
         <p:spPr bwMode="auto">
           <a:xfrm flipH="0" flipV="0">
-            <a:off x="838199" y="1825624"/>
+            <a:off x="838198" y="1825624"/>
             <a:ext cx="5736168" cy="4351338"/>
           </a:xfrm>
         </p:spPr>
@@ -4408,6 +4491,115 @@
           </a:prstGeom>
         </p:spPr>
       </p:pic>
+    </p:spTree>
+  </p:cSld>
+  <p:clrMapOvr>
+    <a:masterClrMapping/>
+  </p:clrMapOvr>
+  <mc:AlternateContent xmlns:mc="http://schemas.openxmlformats.org/markup-compatibility/2006">
+    <mc:Choice xmlns:p159="http://schemas.microsoft.com/office/powerpoint/2015/09/main" xmlns:p14="http://schemas.microsoft.com/office/powerpoint/2010/main" Requires="p159">
+      <p:transition p14:dur="2000" advClick="1"/>
+    </mc:Choice>
+    <mc:Fallback>
+      <p:transition advClick="1"/>
+    </mc:Fallback>
+  </mc:AlternateContent>
+</p:sld>
+</file>
+
+<file path=ppt/slides/slide4.xml><?xml version="1.0" encoding="utf-8"?>
+<p:sld xmlns:a="http://schemas.openxmlformats.org/drawingml/2006/main" xmlns:r="http://schemas.openxmlformats.org/officeDocument/2006/relationships" xmlns:p="http://schemas.openxmlformats.org/presentationml/2006/main" xmlns:m="http://schemas.openxmlformats.org/officeDocument/2006/math" xmlns:w="http://schemas.openxmlformats.org/wordprocessingml/2006/main" xmlns:mc="http://schemas.openxmlformats.org/markup-compatibility/2006" showMasterPhAnim="0" showMasterSp="1" show="1">
+  <p:cSld name="">
+    <p:spTree>
+      <p:nvGrpSpPr>
+        <p:cNvPr id="1" name=""/>
+        <p:cNvGrpSpPr/>
+        <p:nvPr/>
+      </p:nvGrpSpPr>
+      <p:grpSpPr bwMode="auto">
+        <a:xfrm>
+          <a:off x="0" y="0"/>
+          <a:ext cx="0" cy="0"/>
+          <a:chOff x="0" y="0"/>
+          <a:chExt cx="0" cy="0"/>
+        </a:xfrm>
+      </p:grpSpPr>
+      <p:sp>
+        <p:nvSpPr>
+          <p:cNvPr id="592984400" name="Titre 1"/>
+          <p:cNvSpPr>
+            <a:spLocks noGrp="1"/>
+          </p:cNvSpPr>
+          <p:nvPr>
+            <p:ph type="title"/>
+          </p:nvPr>
+        </p:nvSpPr>
+        <p:spPr bwMode="auto"/>
+        <p:txBody>
+          <a:bodyPr/>
+          <a:lstStyle/>
+          <a:p>
+            <a:pPr>
+              <a:defRPr/>
+            </a:pPr>
+            <a:endParaRPr/>
+          </a:p>
+        </p:txBody>
+      </p:sp>
+      <p:sp>
+        <p:nvSpPr>
+          <p:cNvPr id="638208209" name="Espace réservé du contenu 2"/>
+          <p:cNvSpPr>
+            <a:spLocks noGrp="1"/>
+          </p:cNvSpPr>
+          <p:nvPr>
+            <p:ph sz="half" idx="1"/>
+          </p:nvPr>
+        </p:nvSpPr>
+        <p:spPr bwMode="auto">
+          <a:xfrm>
+            <a:off x="838199" y="1825624"/>
+            <a:ext cx="5181599" cy="4351338"/>
+          </a:xfrm>
+        </p:spPr>
+        <p:txBody>
+          <a:bodyPr/>
+          <a:lstStyle/>
+          <a:p>
+            <a:pPr>
+              <a:defRPr/>
+            </a:pPr>
+            <a:endParaRPr/>
+          </a:p>
+        </p:txBody>
+      </p:sp>
+      <p:sp>
+        <p:nvSpPr>
+          <p:cNvPr id="423244823" name="Espace réservé du contenu 3"/>
+          <p:cNvSpPr>
+            <a:spLocks noGrp="1"/>
+          </p:cNvSpPr>
+          <p:nvPr>
+            <p:ph sz="half" idx="2"/>
+          </p:nvPr>
+        </p:nvSpPr>
+        <p:spPr bwMode="auto">
+          <a:xfrm>
+            <a:off x="6172200" y="1825624"/>
+            <a:ext cx="5181599" cy="4351338"/>
+          </a:xfrm>
+        </p:spPr>
+        <p:txBody>
+          <a:bodyPr/>
+          <a:lstStyle/>
+          <a:p>
+            <a:pPr>
+              <a:defRPr/>
+            </a:pPr>
+            <a:endParaRPr/>
+          </a:p>
+        </p:txBody>
+      </p:sp>
     </p:spTree>
   </p:cSld>
   <p:clrMapOvr>

</xml_diff>

<commit_message>
Add the ppt slides
</commit_message>
<xml_diff>
--- a/CP_project_midterm_presentation.pptx
+++ b/CP_project_midterm_presentation.pptx
@@ -5,13 +5,19 @@
     <p:sldMasterId id="2147483648" r:id="rId1"/>
   </p:sldMasterIdLst>
   <p:notesMasterIdLst>
-    <p:notesMasterId r:id="rId8"/>
+    <p:notesMasterId r:id="rId14"/>
   </p:notesMasterIdLst>
   <p:sldIdLst>
     <p:sldId id="256" r:id="rId4"/>
     <p:sldId id="257" r:id="rId5"/>
     <p:sldId id="258" r:id="rId6"/>
     <p:sldId id="259" r:id="rId7"/>
+    <p:sldId id="260" r:id="rId8"/>
+    <p:sldId id="261" r:id="rId9"/>
+    <p:sldId id="262" r:id="rId10"/>
+    <p:sldId id="263" r:id="rId11"/>
+    <p:sldId id="264" r:id="rId12"/>
+    <p:sldId id="265" r:id="rId13"/>
   </p:sldIdLst>
   <p:sldSz cx="12192000" cy="6858000"/>
   <p:notesSz cx="6858000" cy="9144000"/>
@@ -577,6 +583,88 @@
 </p:notes>
 </file>
 
+<file path=ppt/notesSlides/notesSlide10.xml><?xml version="1.0" encoding="utf-8"?>
+<p:notes xmlns:a="http://schemas.openxmlformats.org/drawingml/2006/main" xmlns:r="http://schemas.openxmlformats.org/officeDocument/2006/relationships" xmlns:p="http://schemas.openxmlformats.org/presentationml/2006/main" xmlns:m="http://schemas.openxmlformats.org/officeDocument/2006/math" xmlns:w="http://schemas.openxmlformats.org/wordprocessingml/2006/main">
+  <p:cSld name="">
+    <p:spTree>
+      <p:nvGrpSpPr>
+        <p:cNvPr id="1" name=""/>
+        <p:cNvGrpSpPr/>
+        <p:nvPr/>
+      </p:nvGrpSpPr>
+      <p:grpSpPr bwMode="auto">
+        <a:xfrm>
+          <a:off x="0" y="0"/>
+          <a:ext cx="0" cy="0"/>
+          <a:chOff x="0" y="0"/>
+          <a:chExt cx="0" cy="0"/>
+        </a:xfrm>
+      </p:grpSpPr>
+      <p:sp>
+        <p:nvSpPr>
+          <p:cNvPr id="383911843" name="Slide Image Placeholder 1"/>
+          <p:cNvSpPr>
+            <a:spLocks noChangeAspect="1" noGrp="1" noRot="1"/>
+          </p:cNvSpPr>
+          <p:nvPr>
+            <p:ph type="sldImg"/>
+          </p:nvPr>
+        </p:nvSpPr>
+        <p:spPr bwMode="auto"/>
+      </p:sp>
+      <p:sp>
+        <p:nvSpPr>
+          <p:cNvPr id="981411662" name="Notes Placeholder 2"/>
+          <p:cNvSpPr>
+            <a:spLocks noGrp="1"/>
+          </p:cNvSpPr>
+          <p:nvPr>
+            <p:ph type="body" idx="1"/>
+          </p:nvPr>
+        </p:nvSpPr>
+        <p:spPr bwMode="auto"/>
+        <p:txBody>
+          <a:bodyPr/>
+          <a:lstStyle/>
+          <a:p>
+            <a:pPr>
+              <a:defRPr/>
+            </a:pPr>
+            <a:endParaRPr/>
+          </a:p>
+        </p:txBody>
+      </p:sp>
+      <p:sp>
+        <p:nvSpPr>
+          <p:cNvPr id="285377725" name="Slide Number Placeholder 3"/>
+          <p:cNvSpPr>
+            <a:spLocks noGrp="1"/>
+          </p:cNvSpPr>
+          <p:nvPr>
+            <p:ph type="sldNum" sz="quarter" idx="10"/>
+          </p:nvPr>
+        </p:nvSpPr>
+        <p:spPr bwMode="auto"/>
+        <p:txBody>
+          <a:bodyPr/>
+          <a:lstStyle/>
+          <a:p>
+            <a:pPr>
+              <a:defRPr/>
+            </a:pPr>
+            <a:fld id="{826BC408-41BF-BDDA-C064-32D410CB2907}" type="slidenum">
+              <a:rPr/>
+              <a:t/>
+            </a:fld>
+            <a:endParaRPr/>
+          </a:p>
+        </p:txBody>
+      </p:sp>
+    </p:spTree>
+  </p:cSld>
+</p:notes>
+</file>
+
 <file path=ppt/notesSlides/notesSlide2.xml><?xml version="1.0" encoding="utf-8"?>
 <p:notes xmlns:a="http://schemas.openxmlformats.org/drawingml/2006/main" xmlns:r="http://schemas.openxmlformats.org/officeDocument/2006/relationships" xmlns:p="http://schemas.openxmlformats.org/presentationml/2006/main" xmlns:m="http://schemas.openxmlformats.org/officeDocument/2006/math" xmlns:w="http://schemas.openxmlformats.org/wordprocessingml/2006/main">
   <p:cSld name="">
@@ -678,7 +766,7 @@
       </p:grpSpPr>
       <p:sp>
         <p:nvSpPr>
-          <p:cNvPr id="2" name="Slide Image Placeholder 1"/>
+          <p:cNvPr id="322134409" name="Slide Image Placeholder 1"/>
           <p:cNvSpPr>
             <a:spLocks noChangeAspect="1" noGrp="1" noRot="1"/>
           </p:cNvSpPr>
@@ -690,7 +778,7 @@
       </p:sp>
       <p:sp>
         <p:nvSpPr>
-          <p:cNvPr id="3" name="Notes Placeholder 2"/>
+          <p:cNvPr id="2106916729" name="Notes Placeholder 2"/>
           <p:cNvSpPr>
             <a:spLocks noGrp="1"/>
           </p:cNvSpPr>
@@ -712,7 +800,7 @@
       </p:sp>
       <p:sp>
         <p:nvSpPr>
-          <p:cNvPr id="4" name="Slide Number Placeholder 3"/>
+          <p:cNvPr id="946296806" name="Slide Number Placeholder 3"/>
           <p:cNvSpPr>
             <a:spLocks noGrp="1"/>
           </p:cNvSpPr>
@@ -728,7 +816,7 @@
             <a:pPr>
               <a:defRPr/>
             </a:pPr>
-            <a:fld id="{4E8DC1ED-EF3A-9096-071B-094DF0595504}" type="slidenum">
+            <a:fld id="{0C9024D1-8D77-8467-61A5-98346701E855}" type="slidenum">
               <a:rPr/>
               <a:t/>
             </a:fld>
@@ -760,7 +848,7 @@
       </p:grpSpPr>
       <p:sp>
         <p:nvSpPr>
-          <p:cNvPr id="2" name="Slide Image Placeholder 1"/>
+          <p:cNvPr id="469818513" name="Slide Image Placeholder 1"/>
           <p:cNvSpPr>
             <a:spLocks noChangeAspect="1" noGrp="1" noRot="1"/>
           </p:cNvSpPr>
@@ -772,7 +860,7 @@
       </p:sp>
       <p:sp>
         <p:nvSpPr>
-          <p:cNvPr id="3" name="Notes Placeholder 2"/>
+          <p:cNvPr id="1204960332" name="Notes Placeholder 2"/>
           <p:cNvSpPr>
             <a:spLocks noGrp="1"/>
           </p:cNvSpPr>
@@ -794,7 +882,7 @@
       </p:sp>
       <p:sp>
         <p:nvSpPr>
-          <p:cNvPr id="4" name="Slide Number Placeholder 3"/>
+          <p:cNvPr id="473556765" name="Slide Number Placeholder 3"/>
           <p:cNvSpPr>
             <a:spLocks noGrp="1"/>
           </p:cNvSpPr>
@@ -810,7 +898,417 @@
             <a:pPr>
               <a:defRPr/>
             </a:pPr>
-            <a:fld id="{0C6F982C-9ABE-BEB3-A98B-6AA777F6DAAD}" type="slidenum">
+            <a:fld id="{8B5DE2A0-E408-00F9-EF00-EB687678E380}" type="slidenum">
+              <a:rPr/>
+              <a:t/>
+            </a:fld>
+            <a:endParaRPr/>
+          </a:p>
+        </p:txBody>
+      </p:sp>
+    </p:spTree>
+  </p:cSld>
+</p:notes>
+</file>
+
+<file path=ppt/notesSlides/notesSlide5.xml><?xml version="1.0" encoding="utf-8"?>
+<p:notes xmlns:a="http://schemas.openxmlformats.org/drawingml/2006/main" xmlns:r="http://schemas.openxmlformats.org/officeDocument/2006/relationships" xmlns:p="http://schemas.openxmlformats.org/presentationml/2006/main" xmlns:m="http://schemas.openxmlformats.org/officeDocument/2006/math" xmlns:w="http://schemas.openxmlformats.org/wordprocessingml/2006/main">
+  <p:cSld name="">
+    <p:spTree>
+      <p:nvGrpSpPr>
+        <p:cNvPr id="1" name=""/>
+        <p:cNvGrpSpPr/>
+        <p:nvPr/>
+      </p:nvGrpSpPr>
+      <p:grpSpPr bwMode="auto">
+        <a:xfrm>
+          <a:off x="0" y="0"/>
+          <a:ext cx="0" cy="0"/>
+          <a:chOff x="0" y="0"/>
+          <a:chExt cx="0" cy="0"/>
+        </a:xfrm>
+      </p:grpSpPr>
+      <p:sp>
+        <p:nvSpPr>
+          <p:cNvPr id="213544283" name="Slide Image Placeholder 1"/>
+          <p:cNvSpPr>
+            <a:spLocks noChangeAspect="1" noGrp="1" noRot="1"/>
+          </p:cNvSpPr>
+          <p:nvPr>
+            <p:ph type="sldImg"/>
+          </p:nvPr>
+        </p:nvSpPr>
+        <p:spPr bwMode="auto"/>
+      </p:sp>
+      <p:sp>
+        <p:nvSpPr>
+          <p:cNvPr id="1337746547" name="Notes Placeholder 2"/>
+          <p:cNvSpPr>
+            <a:spLocks noGrp="1"/>
+          </p:cNvSpPr>
+          <p:nvPr>
+            <p:ph type="body" idx="1"/>
+          </p:nvPr>
+        </p:nvSpPr>
+        <p:spPr bwMode="auto"/>
+        <p:txBody>
+          <a:bodyPr/>
+          <a:lstStyle/>
+          <a:p>
+            <a:pPr>
+              <a:defRPr/>
+            </a:pPr>
+            <a:endParaRPr/>
+          </a:p>
+        </p:txBody>
+      </p:sp>
+      <p:sp>
+        <p:nvSpPr>
+          <p:cNvPr id="742087290" name="Slide Number Placeholder 3"/>
+          <p:cNvSpPr>
+            <a:spLocks noGrp="1"/>
+          </p:cNvSpPr>
+          <p:nvPr>
+            <p:ph type="sldNum" sz="quarter" idx="10"/>
+          </p:nvPr>
+        </p:nvSpPr>
+        <p:spPr bwMode="auto"/>
+        <p:txBody>
+          <a:bodyPr/>
+          <a:lstStyle/>
+          <a:p>
+            <a:pPr>
+              <a:defRPr/>
+            </a:pPr>
+            <a:fld id="{CB5AAC82-58BB-DA95-5D40-1D8CE4859E05}" type="slidenum">
+              <a:rPr/>
+              <a:t/>
+            </a:fld>
+            <a:endParaRPr/>
+          </a:p>
+        </p:txBody>
+      </p:sp>
+    </p:spTree>
+  </p:cSld>
+</p:notes>
+</file>
+
+<file path=ppt/notesSlides/notesSlide6.xml><?xml version="1.0" encoding="utf-8"?>
+<p:notes xmlns:a="http://schemas.openxmlformats.org/drawingml/2006/main" xmlns:r="http://schemas.openxmlformats.org/officeDocument/2006/relationships" xmlns:p="http://schemas.openxmlformats.org/presentationml/2006/main" xmlns:m="http://schemas.openxmlformats.org/officeDocument/2006/math" xmlns:w="http://schemas.openxmlformats.org/wordprocessingml/2006/main">
+  <p:cSld name="">
+    <p:spTree>
+      <p:nvGrpSpPr>
+        <p:cNvPr id="1" name=""/>
+        <p:cNvGrpSpPr/>
+        <p:nvPr/>
+      </p:nvGrpSpPr>
+      <p:grpSpPr bwMode="auto">
+        <a:xfrm>
+          <a:off x="0" y="0"/>
+          <a:ext cx="0" cy="0"/>
+          <a:chOff x="0" y="0"/>
+          <a:chExt cx="0" cy="0"/>
+        </a:xfrm>
+      </p:grpSpPr>
+      <p:sp>
+        <p:nvSpPr>
+          <p:cNvPr id="1698436979" name="Slide Image Placeholder 1"/>
+          <p:cNvSpPr>
+            <a:spLocks noChangeAspect="1" noGrp="1" noRot="1"/>
+          </p:cNvSpPr>
+          <p:nvPr>
+            <p:ph type="sldImg"/>
+          </p:nvPr>
+        </p:nvSpPr>
+        <p:spPr bwMode="auto"/>
+      </p:sp>
+      <p:sp>
+        <p:nvSpPr>
+          <p:cNvPr id="881871836" name="Notes Placeholder 2"/>
+          <p:cNvSpPr>
+            <a:spLocks noGrp="1"/>
+          </p:cNvSpPr>
+          <p:nvPr>
+            <p:ph type="body" idx="1"/>
+          </p:nvPr>
+        </p:nvSpPr>
+        <p:spPr bwMode="auto"/>
+        <p:txBody>
+          <a:bodyPr/>
+          <a:lstStyle/>
+          <a:p>
+            <a:pPr>
+              <a:defRPr/>
+            </a:pPr>
+            <a:endParaRPr/>
+          </a:p>
+        </p:txBody>
+      </p:sp>
+      <p:sp>
+        <p:nvSpPr>
+          <p:cNvPr id="1290538461" name="Slide Number Placeholder 3"/>
+          <p:cNvSpPr>
+            <a:spLocks noGrp="1"/>
+          </p:cNvSpPr>
+          <p:nvPr>
+            <p:ph type="sldNum" sz="quarter" idx="10"/>
+          </p:nvPr>
+        </p:nvSpPr>
+        <p:spPr bwMode="auto"/>
+        <p:txBody>
+          <a:bodyPr/>
+          <a:lstStyle/>
+          <a:p>
+            <a:pPr>
+              <a:defRPr/>
+            </a:pPr>
+            <a:fld id="{8CE5749D-D746-3467-4F72-B8DAD41FA0B9}" type="slidenum">
+              <a:rPr/>
+              <a:t/>
+            </a:fld>
+            <a:endParaRPr/>
+          </a:p>
+        </p:txBody>
+      </p:sp>
+    </p:spTree>
+  </p:cSld>
+</p:notes>
+</file>
+
+<file path=ppt/notesSlides/notesSlide7.xml><?xml version="1.0" encoding="utf-8"?>
+<p:notes xmlns:a="http://schemas.openxmlformats.org/drawingml/2006/main" xmlns:r="http://schemas.openxmlformats.org/officeDocument/2006/relationships" xmlns:p="http://schemas.openxmlformats.org/presentationml/2006/main" xmlns:m="http://schemas.openxmlformats.org/officeDocument/2006/math" xmlns:w="http://schemas.openxmlformats.org/wordprocessingml/2006/main">
+  <p:cSld name="">
+    <p:spTree>
+      <p:nvGrpSpPr>
+        <p:cNvPr id="1" name=""/>
+        <p:cNvGrpSpPr/>
+        <p:nvPr/>
+      </p:nvGrpSpPr>
+      <p:grpSpPr bwMode="auto">
+        <a:xfrm>
+          <a:off x="0" y="0"/>
+          <a:ext cx="0" cy="0"/>
+          <a:chOff x="0" y="0"/>
+          <a:chExt cx="0" cy="0"/>
+        </a:xfrm>
+      </p:grpSpPr>
+      <p:sp>
+        <p:nvSpPr>
+          <p:cNvPr id="982439509" name="Slide Image Placeholder 1"/>
+          <p:cNvSpPr>
+            <a:spLocks noChangeAspect="1" noGrp="1" noRot="1"/>
+          </p:cNvSpPr>
+          <p:nvPr>
+            <p:ph type="sldImg"/>
+          </p:nvPr>
+        </p:nvSpPr>
+        <p:spPr bwMode="auto"/>
+      </p:sp>
+      <p:sp>
+        <p:nvSpPr>
+          <p:cNvPr id="411983964" name="Notes Placeholder 2"/>
+          <p:cNvSpPr>
+            <a:spLocks noGrp="1"/>
+          </p:cNvSpPr>
+          <p:nvPr>
+            <p:ph type="body" idx="1"/>
+          </p:nvPr>
+        </p:nvSpPr>
+        <p:spPr bwMode="auto"/>
+        <p:txBody>
+          <a:bodyPr/>
+          <a:lstStyle/>
+          <a:p>
+            <a:pPr>
+              <a:defRPr/>
+            </a:pPr>
+            <a:endParaRPr/>
+          </a:p>
+        </p:txBody>
+      </p:sp>
+      <p:sp>
+        <p:nvSpPr>
+          <p:cNvPr id="1909732534" name="Slide Number Placeholder 3"/>
+          <p:cNvSpPr>
+            <a:spLocks noGrp="1"/>
+          </p:cNvSpPr>
+          <p:nvPr>
+            <p:ph type="sldNum" sz="quarter" idx="10"/>
+          </p:nvPr>
+        </p:nvSpPr>
+        <p:spPr bwMode="auto"/>
+        <p:txBody>
+          <a:bodyPr/>
+          <a:lstStyle/>
+          <a:p>
+            <a:pPr>
+              <a:defRPr/>
+            </a:pPr>
+            <a:fld id="{079701E9-0B8F-FE32-DAE1-697CEA162A28}" type="slidenum">
+              <a:rPr/>
+              <a:t/>
+            </a:fld>
+            <a:endParaRPr/>
+          </a:p>
+        </p:txBody>
+      </p:sp>
+    </p:spTree>
+  </p:cSld>
+</p:notes>
+</file>
+
+<file path=ppt/notesSlides/notesSlide8.xml><?xml version="1.0" encoding="utf-8"?>
+<p:notes xmlns:a="http://schemas.openxmlformats.org/drawingml/2006/main" xmlns:r="http://schemas.openxmlformats.org/officeDocument/2006/relationships" xmlns:p="http://schemas.openxmlformats.org/presentationml/2006/main" xmlns:m="http://schemas.openxmlformats.org/officeDocument/2006/math" xmlns:w="http://schemas.openxmlformats.org/wordprocessingml/2006/main">
+  <p:cSld name="">
+    <p:spTree>
+      <p:nvGrpSpPr>
+        <p:cNvPr id="1" name=""/>
+        <p:cNvGrpSpPr/>
+        <p:nvPr/>
+      </p:nvGrpSpPr>
+      <p:grpSpPr bwMode="auto">
+        <a:xfrm>
+          <a:off x="0" y="0"/>
+          <a:ext cx="0" cy="0"/>
+          <a:chOff x="0" y="0"/>
+          <a:chExt cx="0" cy="0"/>
+        </a:xfrm>
+      </p:grpSpPr>
+      <p:sp>
+        <p:nvSpPr>
+          <p:cNvPr id="322133665" name="Slide Image Placeholder 1"/>
+          <p:cNvSpPr>
+            <a:spLocks noChangeAspect="1" noGrp="1" noRot="1"/>
+          </p:cNvSpPr>
+          <p:nvPr>
+            <p:ph type="sldImg"/>
+          </p:nvPr>
+        </p:nvSpPr>
+        <p:spPr bwMode="auto"/>
+      </p:sp>
+      <p:sp>
+        <p:nvSpPr>
+          <p:cNvPr id="178006936" name="Notes Placeholder 2"/>
+          <p:cNvSpPr>
+            <a:spLocks noGrp="1"/>
+          </p:cNvSpPr>
+          <p:nvPr>
+            <p:ph type="body" idx="1"/>
+          </p:nvPr>
+        </p:nvSpPr>
+        <p:spPr bwMode="auto"/>
+        <p:txBody>
+          <a:bodyPr/>
+          <a:lstStyle/>
+          <a:p>
+            <a:pPr>
+              <a:defRPr/>
+            </a:pPr>
+            <a:endParaRPr/>
+          </a:p>
+        </p:txBody>
+      </p:sp>
+      <p:sp>
+        <p:nvSpPr>
+          <p:cNvPr id="1684290143" name="Slide Number Placeholder 3"/>
+          <p:cNvSpPr>
+            <a:spLocks noGrp="1"/>
+          </p:cNvSpPr>
+          <p:nvPr>
+            <p:ph type="sldNum" sz="quarter" idx="10"/>
+          </p:nvPr>
+        </p:nvSpPr>
+        <p:spPr bwMode="auto"/>
+        <p:txBody>
+          <a:bodyPr/>
+          <a:lstStyle/>
+          <a:p>
+            <a:pPr>
+              <a:defRPr/>
+            </a:pPr>
+            <a:fld id="{2F581F3E-76B3-7453-A2E5-4E1E014751AB}" type="slidenum">
+              <a:rPr/>
+              <a:t/>
+            </a:fld>
+            <a:endParaRPr/>
+          </a:p>
+        </p:txBody>
+      </p:sp>
+    </p:spTree>
+  </p:cSld>
+</p:notes>
+</file>
+
+<file path=ppt/notesSlides/notesSlide9.xml><?xml version="1.0" encoding="utf-8"?>
+<p:notes xmlns:a="http://schemas.openxmlformats.org/drawingml/2006/main" xmlns:r="http://schemas.openxmlformats.org/officeDocument/2006/relationships" xmlns:p="http://schemas.openxmlformats.org/presentationml/2006/main" xmlns:m="http://schemas.openxmlformats.org/officeDocument/2006/math" xmlns:w="http://schemas.openxmlformats.org/wordprocessingml/2006/main">
+  <p:cSld name="">
+    <p:spTree>
+      <p:nvGrpSpPr>
+        <p:cNvPr id="1" name=""/>
+        <p:cNvGrpSpPr/>
+        <p:nvPr/>
+      </p:nvGrpSpPr>
+      <p:grpSpPr bwMode="auto">
+        <a:xfrm>
+          <a:off x="0" y="0"/>
+          <a:ext cx="0" cy="0"/>
+          <a:chOff x="0" y="0"/>
+          <a:chExt cx="0" cy="0"/>
+        </a:xfrm>
+      </p:grpSpPr>
+      <p:sp>
+        <p:nvSpPr>
+          <p:cNvPr id="726988231" name="Slide Image Placeholder 1"/>
+          <p:cNvSpPr>
+            <a:spLocks noChangeAspect="1" noGrp="1" noRot="1"/>
+          </p:cNvSpPr>
+          <p:nvPr>
+            <p:ph type="sldImg"/>
+          </p:nvPr>
+        </p:nvSpPr>
+        <p:spPr bwMode="auto"/>
+      </p:sp>
+      <p:sp>
+        <p:nvSpPr>
+          <p:cNvPr id="1024406211" name="Notes Placeholder 2"/>
+          <p:cNvSpPr>
+            <a:spLocks noGrp="1"/>
+          </p:cNvSpPr>
+          <p:nvPr>
+            <p:ph type="body" idx="1"/>
+          </p:nvPr>
+        </p:nvSpPr>
+        <p:spPr bwMode="auto"/>
+        <p:txBody>
+          <a:bodyPr/>
+          <a:lstStyle/>
+          <a:p>
+            <a:pPr>
+              <a:defRPr/>
+            </a:pPr>
+            <a:endParaRPr/>
+          </a:p>
+        </p:txBody>
+      </p:sp>
+      <p:sp>
+        <p:nvSpPr>
+          <p:cNvPr id="1704330064" name="Slide Number Placeholder 3"/>
+          <p:cNvSpPr>
+            <a:spLocks noGrp="1"/>
+          </p:cNvSpPr>
+          <p:nvPr>
+            <p:ph type="sldNum" sz="quarter" idx="10"/>
+          </p:nvPr>
+        </p:nvSpPr>
+        <p:spPr bwMode="auto"/>
+        <p:txBody>
+          <a:bodyPr/>
+          <a:lstStyle/>
+          <a:p>
+            <a:pPr>
+              <a:defRPr/>
+            </a:pPr>
+            <a:fld id="{5FAF3B4D-4C5E-ECA8-6B35-B15869A4108B}" type="slidenum">
               <a:rPr/>
               <a:t/>
             </a:fld>
@@ -4045,6 +4543,131 @@
 </p:sld>
 </file>
 
+<file path=ppt/slides/slide10.xml><?xml version="1.0" encoding="utf-8"?>
+<p:sld xmlns:a="http://schemas.openxmlformats.org/drawingml/2006/main" xmlns:r="http://schemas.openxmlformats.org/officeDocument/2006/relationships" xmlns:p="http://schemas.openxmlformats.org/presentationml/2006/main" xmlns:m="http://schemas.openxmlformats.org/officeDocument/2006/math" xmlns:w="http://schemas.openxmlformats.org/wordprocessingml/2006/main" xmlns:mc="http://schemas.openxmlformats.org/markup-compatibility/2006" showMasterPhAnim="0" showMasterSp="1" show="1">
+  <p:cSld name="">
+    <p:spTree>
+      <p:nvGrpSpPr>
+        <p:cNvPr id="1" name=""/>
+        <p:cNvGrpSpPr/>
+        <p:nvPr/>
+      </p:nvGrpSpPr>
+      <p:grpSpPr bwMode="auto">
+        <a:xfrm>
+          <a:off x="0" y="0"/>
+          <a:ext cx="0" cy="0"/>
+          <a:chOff x="0" y="0"/>
+          <a:chExt cx="0" cy="0"/>
+        </a:xfrm>
+      </p:grpSpPr>
+      <p:sp>
+        <p:nvSpPr>
+          <p:cNvPr id="250321262" name="Titre 1"/>
+          <p:cNvSpPr>
+            <a:spLocks noGrp="1"/>
+          </p:cNvSpPr>
+          <p:nvPr>
+            <p:ph type="title"/>
+          </p:nvPr>
+        </p:nvSpPr>
+        <p:spPr bwMode="auto"/>
+        <p:txBody>
+          <a:bodyPr/>
+          <a:lstStyle/>
+          <a:p>
+            <a:pPr>
+              <a:defRPr/>
+            </a:pPr>
+            <a:r>
+              <a:rPr/>
+              <a:t>Part 3 : 2</a:t>
+            </a:r>
+            <a:r>
+              <a:rPr baseline="30000"/>
+              <a:t>k</a:t>
+            </a:r>
+            <a:r>
+              <a:rPr sz="3600"/>
+              <a:t> Factorial Design</a:t>
+            </a:r>
+            <a:endParaRPr/>
+          </a:p>
+        </p:txBody>
+      </p:sp>
+      <p:sp>
+        <p:nvSpPr>
+          <p:cNvPr id="1094789569" name="Espace réservé du contenu 2"/>
+          <p:cNvSpPr>
+            <a:spLocks noGrp="1"/>
+          </p:cNvSpPr>
+          <p:nvPr>
+            <p:ph sz="half" idx="1"/>
+          </p:nvPr>
+        </p:nvSpPr>
+        <p:spPr bwMode="auto">
+          <a:xfrm>
+            <a:off x="838197" y="1825623"/>
+            <a:ext cx="5181598" cy="4351338"/>
+          </a:xfrm>
+        </p:spPr>
+        <p:txBody>
+          <a:bodyPr/>
+          <a:lstStyle/>
+          <a:p>
+            <a:pPr>
+              <a:defRPr/>
+            </a:pPr>
+            <a:r>
+              <a:rPr/>
+              <a:t>Selected Features</a:t>
+            </a:r>
+            <a:endParaRPr/>
+          </a:p>
+        </p:txBody>
+      </p:sp>
+      <p:sp>
+        <p:nvSpPr>
+          <p:cNvPr id="1498739112" name="Espace réservé du contenu 3"/>
+          <p:cNvSpPr>
+            <a:spLocks noGrp="1"/>
+          </p:cNvSpPr>
+          <p:nvPr>
+            <p:ph sz="half" idx="2"/>
+          </p:nvPr>
+        </p:nvSpPr>
+        <p:spPr bwMode="auto">
+          <a:xfrm>
+            <a:off x="6172200" y="1825623"/>
+            <a:ext cx="5181598" cy="4351338"/>
+          </a:xfrm>
+        </p:spPr>
+        <p:txBody>
+          <a:bodyPr/>
+          <a:lstStyle/>
+          <a:p>
+            <a:pPr>
+              <a:defRPr/>
+            </a:pPr>
+            <a:endParaRPr/>
+          </a:p>
+        </p:txBody>
+      </p:sp>
+    </p:spTree>
+  </p:cSld>
+  <p:clrMapOvr>
+    <a:masterClrMapping/>
+  </p:clrMapOvr>
+  <mc:AlternateContent xmlns:mc="http://schemas.openxmlformats.org/markup-compatibility/2006">
+    <mc:Choice xmlns:p159="http://schemas.microsoft.com/office/powerpoint/2015/09/main" xmlns:p14="http://schemas.microsoft.com/office/powerpoint/2010/main" Requires="p159">
+      <p:transition p14:dur="2000" advClick="1"/>
+    </mc:Choice>
+    <mc:Fallback>
+      <p:transition advClick="1"/>
+    </mc:Fallback>
+  </mc:AlternateContent>
+</p:sld>
+</file>
+
 <file path=ppt/slides/slide2.xml><?xml version="1.0" encoding="utf-8"?>
 <p:sld xmlns:a="http://schemas.openxmlformats.org/drawingml/2006/main" xmlns:r="http://schemas.openxmlformats.org/officeDocument/2006/relationships" xmlns:p="http://schemas.openxmlformats.org/presentationml/2006/main" xmlns:m="http://schemas.openxmlformats.org/officeDocument/2006/math" xmlns:w="http://schemas.openxmlformats.org/wordprocessingml/2006/main" xmlns:mc="http://schemas.openxmlformats.org/markup-compatibility/2006" showMasterPhAnim="0" showMasterSp="1" show="1">
   <p:cSld name="">
@@ -4113,7 +4736,7 @@
         </p:spPr>
         <p:txBody>
           <a:bodyPr vertOverflow="overflow" horzOverflow="overflow" vert="horz" wrap="square" lIns="91440" tIns="45720" rIns="91440" bIns="45720" numCol="1" spcCol="0" rtlCol="0" fromWordArt="0" anchor="t" anchorCtr="0" forceAA="0" upright="0" compatLnSpc="0">
-            <a:normAutofit fontScale="70000" lnSpcReduction="6000"/>
+            <a:normAutofit fontScale="60000" lnSpcReduction="8000"/>
           </a:bodyPr>
           <a:lstStyle/>
           <a:p>
@@ -4349,6 +4972,22 @@
               <a:rPr/>
               <a:t>Two training Set</a:t>
             </a:r>
+            <a:endParaRPr/>
+          </a:p>
+          <a:p>
+            <a:pPr lvl="1">
+              <a:defRPr/>
+            </a:pPr>
+            <a:r>
+              <a:rPr/>
+              <a:t>Type of Data ?</a:t>
+            </a:r>
+            <a:endParaRPr/>
+          </a:p>
+          <a:p>
+            <a:pPr lvl="2">
+              <a:defRPr/>
+            </a:pPr>
             <a:endParaRPr/>
           </a:p>
           <a:p>
@@ -4430,7 +5069,7 @@
       </p:grpSpPr>
       <p:sp>
         <p:nvSpPr>
-          <p:cNvPr id="1879132274" name="Titre 1"/>
+          <p:cNvPr id="1889332166" name="Titre 1"/>
           <p:cNvSpPr>
             <a:spLocks noGrp="1"/>
           </p:cNvSpPr>
@@ -4471,7 +5110,7 @@
       </p:sp>
       <p:pic>
         <p:nvPicPr>
-          <p:cNvPr id="2089203733" name=""/>
+          <p:cNvPr id="1044638006" name=""/>
           <p:cNvPicPr>
             <a:picLocks noChangeAspect="1"/>
           </p:cNvPicPr>
@@ -4483,8 +5122,8 @@
         </p:blipFill>
         <p:spPr bwMode="auto">
           <a:xfrm flipH="0" flipV="0">
-            <a:off x="669289" y="2084916"/>
-            <a:ext cx="11081067" cy="3621263"/>
+            <a:off x="669288" y="2084915"/>
+            <a:ext cx="11081067" cy="3621262"/>
           </a:xfrm>
           <a:prstGeom prst="rect">
             <a:avLst/>
@@ -4526,7 +5165,7 @@
       </p:grpSpPr>
       <p:sp>
         <p:nvSpPr>
-          <p:cNvPr id="592984400" name="Titre 1"/>
+          <p:cNvPr id="2041334607" name="Titre 1"/>
           <p:cNvSpPr>
             <a:spLocks noGrp="1"/>
           </p:cNvSpPr>
@@ -4542,13 +5181,24 @@
             <a:pPr>
               <a:defRPr/>
             </a:pPr>
-            <a:endParaRPr/>
-          </a:p>
-        </p:txBody>
-      </p:sp>
-      <p:sp>
-        <p:nvSpPr>
-          <p:cNvPr id="638208209" name="Espace réservé du contenu 2"/>
+            <a:r>
+              <a:rPr lang="fr-FR" sz="4400" b="0" i="0" u="none" strike="noStrike" cap="none" spc="0">
+                <a:solidFill>
+                  <a:schemeClr val="tx1"/>
+                </a:solidFill>
+                <a:latin typeface="Arial"/>
+                <a:ea typeface="Arial"/>
+                <a:cs typeface="Arial"/>
+              </a:rPr>
+              <a:t>Classical Statistical Inference</a:t>
+            </a:r>
+            <a:endParaRPr/>
+          </a:p>
+        </p:txBody>
+      </p:sp>
+      <p:sp>
+        <p:nvSpPr>
+          <p:cNvPr id="927797896" name="Espace réservé du contenu 2"/>
           <p:cNvSpPr>
             <a:spLocks noGrp="1"/>
           </p:cNvSpPr>
@@ -4558,8 +5208,8 @@
         </p:nvSpPr>
         <p:spPr bwMode="auto">
           <a:xfrm>
-            <a:off x="838199" y="1825624"/>
-            <a:ext cx="5181599" cy="4351338"/>
+            <a:off x="838197" y="1825623"/>
+            <a:ext cx="5181598" cy="4351338"/>
           </a:xfrm>
         </p:spPr>
         <p:txBody>
@@ -4569,13 +5219,17 @@
             <a:pPr>
               <a:defRPr/>
             </a:pPr>
-            <a:endParaRPr/>
-          </a:p>
-        </p:txBody>
-      </p:sp>
-      <p:sp>
-        <p:nvSpPr>
-          <p:cNvPr id="423244823" name="Espace réservé du contenu 3"/>
+            <a:r>
+              <a:rPr/>
+              <a:t>On SalePrice</a:t>
+            </a:r>
+            <a:endParaRPr/>
+          </a:p>
+        </p:txBody>
+      </p:sp>
+      <p:sp>
+        <p:nvSpPr>
+          <p:cNvPr id="1757296886" name="Espace réservé du contenu 3"/>
           <p:cNvSpPr>
             <a:spLocks noGrp="1"/>
           </p:cNvSpPr>
@@ -4585,8 +5239,757 @@
         </p:nvSpPr>
         <p:spPr bwMode="auto">
           <a:xfrm>
-            <a:off x="6172200" y="1825624"/>
-            <a:ext cx="5181599" cy="4351338"/>
+            <a:off x="6172200" y="1825623"/>
+            <a:ext cx="5181598" cy="4351338"/>
+          </a:xfrm>
+        </p:spPr>
+        <p:txBody>
+          <a:bodyPr/>
+          <a:lstStyle/>
+          <a:p>
+            <a:pPr>
+              <a:defRPr/>
+            </a:pPr>
+            <a:r>
+              <a:rPr/>
+              <a:t>On LogSalePrice</a:t>
+            </a:r>
+            <a:endParaRPr/>
+          </a:p>
+        </p:txBody>
+      </p:sp>
+      <p:pic>
+        <p:nvPicPr>
+          <p:cNvPr id="340210791" name=""/>
+          <p:cNvPicPr>
+            <a:picLocks noChangeAspect="1"/>
+          </p:cNvPicPr>
+          <p:nvPr/>
+        </p:nvPicPr>
+        <p:blipFill>
+          <a:blip r:embed="rId3"/>
+          <a:stretch/>
+        </p:blipFill>
+        <p:spPr bwMode="auto">
+          <a:xfrm>
+            <a:off x="3161043" y="3328515"/>
+            <a:ext cx="1800000" cy="1800000"/>
+          </a:xfrm>
+          <a:prstGeom prst="rect">
+            <a:avLst/>
+          </a:prstGeom>
+        </p:spPr>
+      </p:pic>
+      <p:pic>
+        <p:nvPicPr>
+          <p:cNvPr id="237720757" name=""/>
+          <p:cNvPicPr>
+            <a:picLocks noChangeAspect="1"/>
+          </p:cNvPicPr>
+          <p:nvPr/>
+        </p:nvPicPr>
+        <p:blipFill>
+          <a:blip r:embed="rId4"/>
+          <a:stretch/>
+        </p:blipFill>
+        <p:spPr bwMode="auto">
+          <a:xfrm>
+            <a:off x="0" y="1422927"/>
+            <a:ext cx="12191999" cy="4012141"/>
+          </a:xfrm>
+          <a:prstGeom prst="rect">
+            <a:avLst/>
+          </a:prstGeom>
+        </p:spPr>
+      </p:pic>
+    </p:spTree>
+  </p:cSld>
+  <p:clrMapOvr>
+    <a:masterClrMapping/>
+  </p:clrMapOvr>
+  <mc:AlternateContent xmlns:mc="http://schemas.openxmlformats.org/markup-compatibility/2006">
+    <mc:Choice xmlns:p159="http://schemas.microsoft.com/office/powerpoint/2015/09/main" xmlns:p14="http://schemas.microsoft.com/office/powerpoint/2010/main" Requires="p159">
+      <p:transition p14:dur="2000" advClick="1"/>
+    </mc:Choice>
+    <mc:Fallback>
+      <p:transition advClick="1"/>
+    </mc:Fallback>
+  </mc:AlternateContent>
+</p:sld>
+</file>
+
+<file path=ppt/slides/slide5.xml><?xml version="1.0" encoding="utf-8"?>
+<p:sld xmlns:a="http://schemas.openxmlformats.org/drawingml/2006/main" xmlns:r="http://schemas.openxmlformats.org/officeDocument/2006/relationships" xmlns:p="http://schemas.openxmlformats.org/presentationml/2006/main" xmlns:m="http://schemas.openxmlformats.org/officeDocument/2006/math" xmlns:w="http://schemas.openxmlformats.org/wordprocessingml/2006/main" xmlns:mc="http://schemas.openxmlformats.org/markup-compatibility/2006" showMasterPhAnim="0" showMasterSp="1" show="1">
+  <p:cSld name="">
+    <p:spTree>
+      <p:nvGrpSpPr>
+        <p:cNvPr id="1" name=""/>
+        <p:cNvGrpSpPr/>
+        <p:nvPr/>
+      </p:nvGrpSpPr>
+      <p:grpSpPr bwMode="auto">
+        <a:xfrm>
+          <a:off x="0" y="0"/>
+          <a:ext cx="0" cy="0"/>
+          <a:chOff x="0" y="0"/>
+          <a:chExt cx="0" cy="0"/>
+        </a:xfrm>
+      </p:grpSpPr>
+      <p:sp>
+        <p:nvSpPr>
+          <p:cNvPr id="400933292" name="Titre 1"/>
+          <p:cNvSpPr>
+            <a:spLocks noGrp="1"/>
+          </p:cNvSpPr>
+          <p:nvPr>
+            <p:ph type="title"/>
+          </p:nvPr>
+        </p:nvSpPr>
+        <p:spPr bwMode="auto"/>
+        <p:txBody>
+          <a:bodyPr/>
+          <a:lstStyle/>
+          <a:p>
+            <a:pPr>
+              <a:defRPr/>
+            </a:pPr>
+            <a:r>
+              <a:rPr lang="fr-FR" sz="4400" b="0" i="0" u="none" strike="noStrike" cap="none" spc="0">
+                <a:solidFill>
+                  <a:schemeClr val="tx1"/>
+                </a:solidFill>
+                <a:latin typeface="Arial"/>
+                <a:ea typeface="Arial"/>
+                <a:cs typeface="Arial"/>
+              </a:rPr>
+              <a:t>Classical Statistical Inference</a:t>
+            </a:r>
+            <a:endParaRPr/>
+          </a:p>
+        </p:txBody>
+      </p:sp>
+      <p:pic>
+        <p:nvPicPr>
+          <p:cNvPr id="44824075" name=""/>
+          <p:cNvPicPr>
+            <a:picLocks noChangeAspect="1"/>
+          </p:cNvPicPr>
+          <p:nvPr/>
+        </p:nvPicPr>
+        <p:blipFill>
+          <a:blip r:embed="rId3"/>
+          <a:stretch/>
+        </p:blipFill>
+        <p:spPr bwMode="auto">
+          <a:xfrm>
+            <a:off x="3161043" y="3328515"/>
+            <a:ext cx="1800000" cy="1800000"/>
+          </a:xfrm>
+          <a:prstGeom prst="rect">
+            <a:avLst/>
+          </a:prstGeom>
+        </p:spPr>
+      </p:pic>
+      <p:pic>
+        <p:nvPicPr>
+          <p:cNvPr id="614926550" name=""/>
+          <p:cNvPicPr>
+            <a:picLocks noChangeAspect="1"/>
+          </p:cNvPicPr>
+          <p:nvPr/>
+        </p:nvPicPr>
+        <p:blipFill>
+          <a:blip r:embed="rId4"/>
+          <a:stretch/>
+        </p:blipFill>
+        <p:spPr bwMode="auto">
+          <a:xfrm flipH="0" flipV="0">
+            <a:off x="1778348" y="1375499"/>
+            <a:ext cx="7957063" cy="5342599"/>
+          </a:xfrm>
+          <a:prstGeom prst="rect">
+            <a:avLst/>
+          </a:prstGeom>
+        </p:spPr>
+      </p:pic>
+    </p:spTree>
+  </p:cSld>
+  <p:clrMapOvr>
+    <a:masterClrMapping/>
+  </p:clrMapOvr>
+  <mc:AlternateContent xmlns:mc="http://schemas.openxmlformats.org/markup-compatibility/2006">
+    <mc:Choice xmlns:p159="http://schemas.microsoft.com/office/powerpoint/2015/09/main" xmlns:p14="http://schemas.microsoft.com/office/powerpoint/2010/main" Requires="p159">
+      <p:transition p14:dur="2000" advClick="1"/>
+    </mc:Choice>
+    <mc:Fallback>
+      <p:transition advClick="1"/>
+    </mc:Fallback>
+  </mc:AlternateContent>
+</p:sld>
+</file>
+
+<file path=ppt/slides/slide6.xml><?xml version="1.0" encoding="utf-8"?>
+<p:sld xmlns:a="http://schemas.openxmlformats.org/drawingml/2006/main" xmlns:r="http://schemas.openxmlformats.org/officeDocument/2006/relationships" xmlns:p="http://schemas.openxmlformats.org/presentationml/2006/main" xmlns:m="http://schemas.openxmlformats.org/officeDocument/2006/math" xmlns:w="http://schemas.openxmlformats.org/wordprocessingml/2006/main" xmlns:mc="http://schemas.openxmlformats.org/markup-compatibility/2006" showMasterPhAnim="0" showMasterSp="1" show="1">
+  <p:cSld name="">
+    <p:spTree>
+      <p:nvGrpSpPr>
+        <p:cNvPr id="1" name=""/>
+        <p:cNvGrpSpPr/>
+        <p:nvPr/>
+      </p:nvGrpSpPr>
+      <p:grpSpPr bwMode="auto">
+        <a:xfrm>
+          <a:off x="0" y="0"/>
+          <a:ext cx="0" cy="0"/>
+          <a:chOff x="0" y="0"/>
+          <a:chExt cx="0" cy="0"/>
+        </a:xfrm>
+      </p:grpSpPr>
+      <p:sp>
+        <p:nvSpPr>
+          <p:cNvPr id="1603570309" name="Titre 1"/>
+          <p:cNvSpPr>
+            <a:spLocks noGrp="1"/>
+          </p:cNvSpPr>
+          <p:nvPr>
+            <p:ph type="title"/>
+          </p:nvPr>
+        </p:nvSpPr>
+        <p:spPr bwMode="auto"/>
+        <p:txBody>
+          <a:bodyPr/>
+          <a:lstStyle/>
+          <a:p>
+            <a:pPr>
+              <a:defRPr/>
+            </a:pPr>
+            <a:r>
+              <a:rPr/>
+              <a:t>Part 2 : ANOVA – significant features</a:t>
+            </a:r>
+            <a:endParaRPr/>
+          </a:p>
+        </p:txBody>
+      </p:sp>
+      <p:sp>
+        <p:nvSpPr>
+          <p:cNvPr id="183844190" name="Espace réservé du contenu 2"/>
+          <p:cNvSpPr>
+            <a:spLocks noGrp="1"/>
+          </p:cNvSpPr>
+          <p:nvPr>
+            <p:ph sz="half" idx="1"/>
+          </p:nvPr>
+        </p:nvSpPr>
+        <p:spPr bwMode="auto">
+          <a:xfrm>
+            <a:off x="838197" y="1825623"/>
+            <a:ext cx="5181598" cy="4351338"/>
+          </a:xfrm>
+        </p:spPr>
+        <p:txBody>
+          <a:bodyPr/>
+          <a:lstStyle/>
+          <a:p>
+            <a:pPr>
+              <a:defRPr/>
+            </a:pPr>
+            <a:r>
+              <a:rPr/>
+              <a:t>One-way ANOVA</a:t>
+            </a:r>
+            <a:endParaRPr/>
+          </a:p>
+          <a:p>
+            <a:pPr>
+              <a:defRPr/>
+            </a:pPr>
+            <a:endParaRPr lang="fr-FR" sz="2800" b="0" i="0" u="none" strike="noStrike" cap="none" spc="0">
+              <a:solidFill>
+                <a:schemeClr val="tx1"/>
+              </a:solidFill>
+              <a:latin typeface="Arial"/>
+              <a:cs typeface="Arial"/>
+            </a:endParaRPr>
+          </a:p>
+        </p:txBody>
+      </p:sp>
+      <p:sp>
+        <p:nvSpPr>
+          <p:cNvPr id="129401849" name="Espace réservé du contenu 3"/>
+          <p:cNvSpPr>
+            <a:spLocks noGrp="1"/>
+          </p:cNvSpPr>
+          <p:nvPr>
+            <p:ph sz="half" idx="2"/>
+          </p:nvPr>
+        </p:nvSpPr>
+        <p:spPr bwMode="auto">
+          <a:xfrm>
+            <a:off x="6423408" y="1825623"/>
+            <a:ext cx="5181598" cy="4351338"/>
+          </a:xfrm>
+        </p:spPr>
+        <p:txBody>
+          <a:bodyPr/>
+          <a:lstStyle/>
+          <a:p>
+            <a:pPr>
+              <a:defRPr/>
+            </a:pPr>
+            <a:r>
+              <a:rPr/>
+              <a:t>Significant features</a:t>
+            </a:r>
+            <a:endParaRPr/>
+          </a:p>
+          <a:p>
+            <a:pPr lvl="1">
+              <a:defRPr/>
+            </a:pPr>
+            <a:r>
+              <a:rPr/>
+              <a:t>OverallQual</a:t>
+            </a:r>
+            <a:endParaRPr/>
+          </a:p>
+          <a:p>
+            <a:pPr lvl="1">
+              <a:defRPr/>
+            </a:pPr>
+            <a:r>
+              <a:rPr/>
+              <a:t>ExterQual</a:t>
+            </a:r>
+            <a:endParaRPr/>
+          </a:p>
+          <a:p>
+            <a:pPr lvl="1">
+              <a:defRPr/>
+            </a:pPr>
+            <a:r>
+              <a:rPr/>
+              <a:t>BsmtQual</a:t>
+            </a:r>
+            <a:endParaRPr/>
+          </a:p>
+          <a:p>
+            <a:pPr lvl="1">
+              <a:defRPr/>
+            </a:pPr>
+            <a:r>
+              <a:rPr/>
+              <a:t>KitchenQual</a:t>
+            </a:r>
+            <a:endParaRPr/>
+          </a:p>
+          <a:p>
+            <a:pPr lvl="1">
+              <a:defRPr/>
+            </a:pPr>
+            <a:r>
+              <a:rPr/>
+              <a:t>FireplaceQu</a:t>
+            </a:r>
+            <a:endParaRPr/>
+          </a:p>
+          <a:p>
+            <a:pPr lvl="1">
+              <a:defRPr/>
+            </a:pPr>
+            <a:r>
+              <a:rPr/>
+              <a:t>CentralAir</a:t>
+            </a:r>
+            <a:endParaRPr/>
+          </a:p>
+          <a:p>
+            <a:pPr lvl="1">
+              <a:defRPr/>
+            </a:pPr>
+            <a:r>
+              <a:rPr/>
+              <a:t>LotShape</a:t>
+            </a:r>
+            <a:endParaRPr/>
+          </a:p>
+        </p:txBody>
+      </p:sp>
+      <p:pic>
+        <p:nvPicPr>
+          <p:cNvPr id="1941661023" name=""/>
+          <p:cNvPicPr>
+            <a:picLocks noChangeAspect="1"/>
+          </p:cNvPicPr>
+          <p:nvPr/>
+        </p:nvPicPr>
+        <p:blipFill>
+          <a:blip r:embed="rId3"/>
+          <a:stretch/>
+        </p:blipFill>
+        <p:spPr bwMode="auto">
+          <a:xfrm flipH="0" flipV="0">
+            <a:off x="838197" y="2518994"/>
+            <a:ext cx="5511493" cy="3122733"/>
+          </a:xfrm>
+          <a:prstGeom prst="rect">
+            <a:avLst/>
+          </a:prstGeom>
+        </p:spPr>
+      </p:pic>
+    </p:spTree>
+  </p:cSld>
+  <p:clrMapOvr>
+    <a:masterClrMapping/>
+  </p:clrMapOvr>
+  <mc:AlternateContent xmlns:mc="http://schemas.openxmlformats.org/markup-compatibility/2006">
+    <mc:Choice xmlns:p159="http://schemas.microsoft.com/office/powerpoint/2015/09/main" xmlns:p14="http://schemas.microsoft.com/office/powerpoint/2010/main" Requires="p159">
+      <p:transition p14:dur="2000" advClick="1"/>
+    </mc:Choice>
+    <mc:Fallback>
+      <p:transition advClick="1"/>
+    </mc:Fallback>
+  </mc:AlternateContent>
+</p:sld>
+</file>
+
+<file path=ppt/slides/slide7.xml><?xml version="1.0" encoding="utf-8"?>
+<p:sld xmlns:a="http://schemas.openxmlformats.org/drawingml/2006/main" xmlns:r="http://schemas.openxmlformats.org/officeDocument/2006/relationships" xmlns:p="http://schemas.openxmlformats.org/presentationml/2006/main" xmlns:m="http://schemas.openxmlformats.org/officeDocument/2006/math" xmlns:w="http://schemas.openxmlformats.org/wordprocessingml/2006/main" xmlns:mc="http://schemas.openxmlformats.org/markup-compatibility/2006" showMasterPhAnim="0" showMasterSp="1" show="1">
+  <p:cSld name="">
+    <p:spTree>
+      <p:nvGrpSpPr>
+        <p:cNvPr id="1" name=""/>
+        <p:cNvGrpSpPr/>
+        <p:nvPr/>
+      </p:nvGrpSpPr>
+      <p:grpSpPr bwMode="auto">
+        <a:xfrm>
+          <a:off x="0" y="0"/>
+          <a:ext cx="0" cy="0"/>
+          <a:chOff x="0" y="0"/>
+          <a:chExt cx="0" cy="0"/>
+        </a:xfrm>
+      </p:grpSpPr>
+      <p:sp>
+        <p:nvSpPr>
+          <p:cNvPr id="103649190" name="Titre 1"/>
+          <p:cNvSpPr>
+            <a:spLocks noGrp="1"/>
+          </p:cNvSpPr>
+          <p:nvPr>
+            <p:ph type="title"/>
+          </p:nvPr>
+        </p:nvSpPr>
+        <p:spPr bwMode="auto"/>
+        <p:txBody>
+          <a:bodyPr/>
+          <a:lstStyle/>
+          <a:p>
+            <a:pPr>
+              <a:defRPr/>
+            </a:pPr>
+            <a:r>
+              <a:rPr lang="fr-FR" sz="4400" b="0" i="0" u="none" strike="noStrike" cap="none" spc="0">
+                <a:solidFill>
+                  <a:schemeClr val="tx1"/>
+                </a:solidFill>
+                <a:latin typeface="Arial"/>
+                <a:ea typeface="Arial"/>
+                <a:cs typeface="Arial"/>
+              </a:rPr>
+              <a:t>Part 2 : ANOVA – significant features</a:t>
+            </a:r>
+            <a:endParaRPr sz="4400"/>
+          </a:p>
+        </p:txBody>
+      </p:sp>
+      <p:sp>
+        <p:nvSpPr>
+          <p:cNvPr id="118347481" name="Espace réservé du contenu 2"/>
+          <p:cNvSpPr>
+            <a:spLocks noGrp="1"/>
+          </p:cNvSpPr>
+          <p:nvPr>
+            <p:ph sz="half" idx="1"/>
+          </p:nvPr>
+        </p:nvSpPr>
+        <p:spPr bwMode="auto">
+          <a:xfrm>
+            <a:off x="838197" y="1825623"/>
+            <a:ext cx="5181598" cy="4351338"/>
+          </a:xfrm>
+        </p:spPr>
+        <p:txBody>
+          <a:bodyPr/>
+          <a:lstStyle/>
+          <a:p>
+            <a:pPr>
+              <a:defRPr/>
+            </a:pPr>
+            <a:endParaRPr/>
+          </a:p>
+        </p:txBody>
+      </p:sp>
+      <p:sp>
+        <p:nvSpPr>
+          <p:cNvPr id="1320543693" name="Espace réservé du contenu 3"/>
+          <p:cNvSpPr>
+            <a:spLocks noGrp="1"/>
+          </p:cNvSpPr>
+          <p:nvPr>
+            <p:ph sz="half" idx="2"/>
+          </p:nvPr>
+        </p:nvSpPr>
+        <p:spPr bwMode="auto">
+          <a:xfrm>
+            <a:off x="6172200" y="1825623"/>
+            <a:ext cx="5181598" cy="4351338"/>
+          </a:xfrm>
+        </p:spPr>
+        <p:txBody>
+          <a:bodyPr/>
+          <a:lstStyle/>
+          <a:p>
+            <a:pPr>
+              <a:defRPr/>
+            </a:pPr>
+            <a:endParaRPr/>
+          </a:p>
+        </p:txBody>
+      </p:sp>
+    </p:spTree>
+  </p:cSld>
+  <p:clrMapOvr>
+    <a:masterClrMapping/>
+  </p:clrMapOvr>
+  <mc:AlternateContent xmlns:mc="http://schemas.openxmlformats.org/markup-compatibility/2006">
+    <mc:Choice xmlns:p159="http://schemas.microsoft.com/office/powerpoint/2015/09/main" xmlns:p14="http://schemas.microsoft.com/office/powerpoint/2010/main" Requires="p159">
+      <p:transition p14:dur="2000" advClick="1"/>
+    </mc:Choice>
+    <mc:Fallback>
+      <p:transition advClick="1"/>
+    </mc:Fallback>
+  </mc:AlternateContent>
+</p:sld>
+</file>
+
+<file path=ppt/slides/slide8.xml><?xml version="1.0" encoding="utf-8"?>
+<p:sld xmlns:a="http://schemas.openxmlformats.org/drawingml/2006/main" xmlns:r="http://schemas.openxmlformats.org/officeDocument/2006/relationships" xmlns:p="http://schemas.openxmlformats.org/presentationml/2006/main" xmlns:m="http://schemas.openxmlformats.org/officeDocument/2006/math" xmlns:w="http://schemas.openxmlformats.org/wordprocessingml/2006/main" xmlns:mc="http://schemas.openxmlformats.org/markup-compatibility/2006" showMasterPhAnim="0" showMasterSp="1" show="1">
+  <p:cSld name="">
+    <p:spTree>
+      <p:nvGrpSpPr>
+        <p:cNvPr id="1" name=""/>
+        <p:cNvGrpSpPr/>
+        <p:nvPr/>
+      </p:nvGrpSpPr>
+      <p:grpSpPr bwMode="auto">
+        <a:xfrm>
+          <a:off x="0" y="0"/>
+          <a:ext cx="0" cy="0"/>
+          <a:chOff x="0" y="0"/>
+          <a:chExt cx="0" cy="0"/>
+        </a:xfrm>
+      </p:grpSpPr>
+      <p:sp>
+        <p:nvSpPr>
+          <p:cNvPr id="932837120" name="Titre 1"/>
+          <p:cNvSpPr>
+            <a:spLocks noGrp="1"/>
+          </p:cNvSpPr>
+          <p:nvPr>
+            <p:ph type="title"/>
+          </p:nvPr>
+        </p:nvSpPr>
+        <p:spPr bwMode="auto"/>
+        <p:txBody>
+          <a:bodyPr/>
+          <a:lstStyle/>
+          <a:p>
+            <a:pPr>
+              <a:defRPr/>
+            </a:pPr>
+            <a:r>
+              <a:rPr/>
+              <a:t>Part 2 : ANOVA – significant features</a:t>
+            </a:r>
+            <a:endParaRPr/>
+          </a:p>
+        </p:txBody>
+      </p:sp>
+      <p:sp>
+        <p:nvSpPr>
+          <p:cNvPr id="1843941217" name="Espace réservé du contenu 2"/>
+          <p:cNvSpPr>
+            <a:spLocks noGrp="1"/>
+          </p:cNvSpPr>
+          <p:nvPr>
+            <p:ph sz="half" idx="1"/>
+          </p:nvPr>
+        </p:nvSpPr>
+        <p:spPr bwMode="auto">
+          <a:xfrm>
+            <a:off x="838197" y="1825623"/>
+            <a:ext cx="5181598" cy="4351338"/>
+          </a:xfrm>
+        </p:spPr>
+        <p:txBody>
+          <a:bodyPr/>
+          <a:lstStyle/>
+          <a:p>
+            <a:pPr>
+              <a:defRPr/>
+            </a:pPr>
+            <a:r>
+              <a:rPr/>
+              <a:t>Tukey HSD</a:t>
+            </a:r>
+            <a:endParaRPr/>
+          </a:p>
+        </p:txBody>
+      </p:sp>
+      <p:sp>
+        <p:nvSpPr>
+          <p:cNvPr id="1262002431" name="Espace réservé du contenu 3"/>
+          <p:cNvSpPr>
+            <a:spLocks noGrp="1"/>
+          </p:cNvSpPr>
+          <p:nvPr>
+            <p:ph sz="half" idx="2"/>
+          </p:nvPr>
+        </p:nvSpPr>
+        <p:spPr bwMode="auto">
+          <a:xfrm>
+            <a:off x="6172200" y="1825623"/>
+            <a:ext cx="5181598" cy="4351338"/>
+          </a:xfrm>
+        </p:spPr>
+        <p:txBody>
+          <a:bodyPr/>
+          <a:lstStyle/>
+          <a:p>
+            <a:pPr>
+              <a:defRPr/>
+            </a:pPr>
+            <a:r>
+              <a:rPr/>
+              <a:t>Significant features</a:t>
+            </a:r>
+            <a:endParaRPr/>
+          </a:p>
+        </p:txBody>
+      </p:sp>
+    </p:spTree>
+  </p:cSld>
+  <p:clrMapOvr>
+    <a:masterClrMapping/>
+  </p:clrMapOvr>
+  <mc:AlternateContent xmlns:mc="http://schemas.openxmlformats.org/markup-compatibility/2006">
+    <mc:Choice xmlns:p159="http://schemas.microsoft.com/office/powerpoint/2015/09/main" xmlns:p14="http://schemas.microsoft.com/office/powerpoint/2010/main" Requires="p159">
+      <p:transition p14:dur="2000" advClick="1"/>
+    </mc:Choice>
+    <mc:Fallback>
+      <p:transition advClick="1"/>
+    </mc:Fallback>
+  </mc:AlternateContent>
+</p:sld>
+</file>
+
+<file path=ppt/slides/slide9.xml><?xml version="1.0" encoding="utf-8"?>
+<p:sld xmlns:a="http://schemas.openxmlformats.org/drawingml/2006/main" xmlns:r="http://schemas.openxmlformats.org/officeDocument/2006/relationships" xmlns:p="http://schemas.openxmlformats.org/presentationml/2006/main" xmlns:m="http://schemas.openxmlformats.org/officeDocument/2006/math" xmlns:w="http://schemas.openxmlformats.org/wordprocessingml/2006/main" xmlns:mc="http://schemas.openxmlformats.org/markup-compatibility/2006" showMasterPhAnim="0" showMasterSp="1" show="1">
+  <p:cSld name="">
+    <p:spTree>
+      <p:nvGrpSpPr>
+        <p:cNvPr id="1" name=""/>
+        <p:cNvGrpSpPr/>
+        <p:nvPr/>
+      </p:nvGrpSpPr>
+      <p:grpSpPr bwMode="auto">
+        <a:xfrm>
+          <a:off x="0" y="0"/>
+          <a:ext cx="0" cy="0"/>
+          <a:chOff x="0" y="0"/>
+          <a:chExt cx="0" cy="0"/>
+        </a:xfrm>
+      </p:grpSpPr>
+      <p:sp>
+        <p:nvSpPr>
+          <p:cNvPr id="1340960394" name="Titre 1"/>
+          <p:cNvSpPr>
+            <a:spLocks noGrp="1"/>
+          </p:cNvSpPr>
+          <p:nvPr>
+            <p:ph type="title"/>
+          </p:nvPr>
+        </p:nvSpPr>
+        <p:spPr bwMode="auto"/>
+        <p:txBody>
+          <a:bodyPr/>
+          <a:lstStyle/>
+          <a:p>
+            <a:pPr>
+              <a:defRPr/>
+            </a:pPr>
+            <a:r>
+              <a:rPr/>
+              <a:t>Part 3 : 2</a:t>
+            </a:r>
+            <a:r>
+              <a:rPr baseline="30000"/>
+              <a:t>k</a:t>
+            </a:r>
+            <a:r>
+              <a:rPr sz="3600"/>
+              <a:t> Factorial Design</a:t>
+            </a:r>
+            <a:endParaRPr/>
+          </a:p>
+        </p:txBody>
+      </p:sp>
+      <p:sp>
+        <p:nvSpPr>
+          <p:cNvPr id="1287313540" name="Espace réservé du contenu 2"/>
+          <p:cNvSpPr>
+            <a:spLocks noGrp="1"/>
+          </p:cNvSpPr>
+          <p:nvPr>
+            <p:ph sz="half" idx="1"/>
+          </p:nvPr>
+        </p:nvSpPr>
+        <p:spPr bwMode="auto">
+          <a:xfrm>
+            <a:off x="838197" y="1825623"/>
+            <a:ext cx="5181598" cy="4351338"/>
+          </a:xfrm>
+        </p:spPr>
+        <p:txBody>
+          <a:bodyPr/>
+          <a:lstStyle/>
+          <a:p>
+            <a:pPr>
+              <a:defRPr/>
+            </a:pPr>
+            <a:r>
+              <a:rPr/>
+              <a:t>Selected Features</a:t>
+            </a:r>
+            <a:endParaRPr/>
+          </a:p>
+        </p:txBody>
+      </p:sp>
+      <p:sp>
+        <p:nvSpPr>
+          <p:cNvPr id="758637506" name="Espace réservé du contenu 3"/>
+          <p:cNvSpPr>
+            <a:spLocks noGrp="1"/>
+          </p:cNvSpPr>
+          <p:nvPr>
+            <p:ph sz="half" idx="2"/>
+          </p:nvPr>
+        </p:nvSpPr>
+        <p:spPr bwMode="auto">
+          <a:xfrm>
+            <a:off x="6172200" y="1825623"/>
+            <a:ext cx="5181598" cy="4351338"/>
           </a:xfrm>
         </p:spPr>
         <p:txBody>

</xml_diff>

<commit_message>
correction in the ppt file
</commit_message>
<xml_diff>
--- a/CP_project_midterm_presentation.pptx
+++ b/CP_project_midterm_presentation.pptx
@@ -5,7 +5,7 @@
     <p:sldMasterId id="2147483648" r:id="rId1"/>
   </p:sldMasterIdLst>
   <p:notesMasterIdLst>
-    <p:notesMasterId r:id="rId14"/>
+    <p:notesMasterId r:id="rId10"/>
   </p:notesMasterIdLst>
   <p:sldIdLst>
     <p:sldId id="256" r:id="rId4"/>
@@ -14,10 +14,6 @@
     <p:sldId id="259" r:id="rId7"/>
     <p:sldId id="260" r:id="rId8"/>
     <p:sldId id="261" r:id="rId9"/>
-    <p:sldId id="262" r:id="rId10"/>
-    <p:sldId id="263" r:id="rId11"/>
-    <p:sldId id="264" r:id="rId12"/>
-    <p:sldId id="265" r:id="rId13"/>
   </p:sldIdLst>
   <p:sldSz cx="12192000" cy="6858000"/>
   <p:notesSz cx="6858000" cy="9144000"/>
@@ -583,88 +579,6 @@
 </p:notes>
 </file>
 
-<file path=ppt/notesSlides/notesSlide10.xml><?xml version="1.0" encoding="utf-8"?>
-<p:notes xmlns:a="http://schemas.openxmlformats.org/drawingml/2006/main" xmlns:r="http://schemas.openxmlformats.org/officeDocument/2006/relationships" xmlns:p="http://schemas.openxmlformats.org/presentationml/2006/main" xmlns:m="http://schemas.openxmlformats.org/officeDocument/2006/math" xmlns:w="http://schemas.openxmlformats.org/wordprocessingml/2006/main">
-  <p:cSld name="">
-    <p:spTree>
-      <p:nvGrpSpPr>
-        <p:cNvPr id="1" name=""/>
-        <p:cNvGrpSpPr/>
-        <p:nvPr/>
-      </p:nvGrpSpPr>
-      <p:grpSpPr bwMode="auto">
-        <a:xfrm>
-          <a:off x="0" y="0"/>
-          <a:ext cx="0" cy="0"/>
-          <a:chOff x="0" y="0"/>
-          <a:chExt cx="0" cy="0"/>
-        </a:xfrm>
-      </p:grpSpPr>
-      <p:sp>
-        <p:nvSpPr>
-          <p:cNvPr id="383911843" name="Slide Image Placeholder 1"/>
-          <p:cNvSpPr>
-            <a:spLocks noChangeAspect="1" noGrp="1" noRot="1"/>
-          </p:cNvSpPr>
-          <p:nvPr>
-            <p:ph type="sldImg"/>
-          </p:nvPr>
-        </p:nvSpPr>
-        <p:spPr bwMode="auto"/>
-      </p:sp>
-      <p:sp>
-        <p:nvSpPr>
-          <p:cNvPr id="981411662" name="Notes Placeholder 2"/>
-          <p:cNvSpPr>
-            <a:spLocks noGrp="1"/>
-          </p:cNvSpPr>
-          <p:nvPr>
-            <p:ph type="body" idx="1"/>
-          </p:nvPr>
-        </p:nvSpPr>
-        <p:spPr bwMode="auto"/>
-        <p:txBody>
-          <a:bodyPr/>
-          <a:lstStyle/>
-          <a:p>
-            <a:pPr>
-              <a:defRPr/>
-            </a:pPr>
-            <a:endParaRPr/>
-          </a:p>
-        </p:txBody>
-      </p:sp>
-      <p:sp>
-        <p:nvSpPr>
-          <p:cNvPr id="285377725" name="Slide Number Placeholder 3"/>
-          <p:cNvSpPr>
-            <a:spLocks noGrp="1"/>
-          </p:cNvSpPr>
-          <p:nvPr>
-            <p:ph type="sldNum" sz="quarter" idx="10"/>
-          </p:nvPr>
-        </p:nvSpPr>
-        <p:spPr bwMode="auto"/>
-        <p:txBody>
-          <a:bodyPr/>
-          <a:lstStyle/>
-          <a:p>
-            <a:pPr>
-              <a:defRPr/>
-            </a:pPr>
-            <a:fld id="{826BC408-41BF-BDDA-C064-32D410CB2907}" type="slidenum">
-              <a:rPr/>
-              <a:t/>
-            </a:fld>
-            <a:endParaRPr/>
-          </a:p>
-        </p:txBody>
-      </p:sp>
-    </p:spTree>
-  </p:cSld>
-</p:notes>
-</file>
-
 <file path=ppt/notesSlides/notesSlide2.xml><?xml version="1.0" encoding="utf-8"?>
 <p:notes xmlns:a="http://schemas.openxmlformats.org/drawingml/2006/main" xmlns:r="http://schemas.openxmlformats.org/officeDocument/2006/relationships" xmlns:p="http://schemas.openxmlformats.org/presentationml/2006/main" xmlns:m="http://schemas.openxmlformats.org/officeDocument/2006/math" xmlns:w="http://schemas.openxmlformats.org/wordprocessingml/2006/main">
   <p:cSld name="">
@@ -766,7 +680,7 @@
       </p:grpSpPr>
       <p:sp>
         <p:nvSpPr>
-          <p:cNvPr id="322134409" name="Slide Image Placeholder 1"/>
+          <p:cNvPr id="469818513" name="Slide Image Placeholder 1"/>
           <p:cNvSpPr>
             <a:spLocks noChangeAspect="1" noGrp="1" noRot="1"/>
           </p:cNvSpPr>
@@ -778,7 +692,7 @@
       </p:sp>
       <p:sp>
         <p:nvSpPr>
-          <p:cNvPr id="2106916729" name="Notes Placeholder 2"/>
+          <p:cNvPr id="1204960332" name="Notes Placeholder 2"/>
           <p:cNvSpPr>
             <a:spLocks noGrp="1"/>
           </p:cNvSpPr>
@@ -800,7 +714,7 @@
       </p:sp>
       <p:sp>
         <p:nvSpPr>
-          <p:cNvPr id="946296806" name="Slide Number Placeholder 3"/>
+          <p:cNvPr id="473556765" name="Slide Number Placeholder 3"/>
           <p:cNvSpPr>
             <a:spLocks noGrp="1"/>
           </p:cNvSpPr>
@@ -816,7 +730,7 @@
             <a:pPr>
               <a:defRPr/>
             </a:pPr>
-            <a:fld id="{0C9024D1-8D77-8467-61A5-98346701E855}" type="slidenum">
+            <a:fld id="{8B5DE2A0-E408-00F9-EF00-EB687678E380}" type="slidenum">
               <a:rPr/>
               <a:t/>
             </a:fld>
@@ -848,7 +762,7 @@
       </p:grpSpPr>
       <p:sp>
         <p:nvSpPr>
-          <p:cNvPr id="469818513" name="Slide Image Placeholder 1"/>
+          <p:cNvPr id="213544283" name="Slide Image Placeholder 1"/>
           <p:cNvSpPr>
             <a:spLocks noChangeAspect="1" noGrp="1" noRot="1"/>
           </p:cNvSpPr>
@@ -860,7 +774,7 @@
       </p:sp>
       <p:sp>
         <p:nvSpPr>
-          <p:cNvPr id="1204960332" name="Notes Placeholder 2"/>
+          <p:cNvPr id="1337746547" name="Notes Placeholder 2"/>
           <p:cNvSpPr>
             <a:spLocks noGrp="1"/>
           </p:cNvSpPr>
@@ -882,7 +796,7 @@
       </p:sp>
       <p:sp>
         <p:nvSpPr>
-          <p:cNvPr id="473556765" name="Slide Number Placeholder 3"/>
+          <p:cNvPr id="742087290" name="Slide Number Placeholder 3"/>
           <p:cNvSpPr>
             <a:spLocks noGrp="1"/>
           </p:cNvSpPr>
@@ -898,7 +812,7 @@
             <a:pPr>
               <a:defRPr/>
             </a:pPr>
-            <a:fld id="{8B5DE2A0-E408-00F9-EF00-EB687678E380}" type="slidenum">
+            <a:fld id="{CB5AAC82-58BB-DA95-5D40-1D8CE4859E05}" type="slidenum">
               <a:rPr/>
               <a:t/>
             </a:fld>
@@ -930,7 +844,7 @@
       </p:grpSpPr>
       <p:sp>
         <p:nvSpPr>
-          <p:cNvPr id="213544283" name="Slide Image Placeholder 1"/>
+          <p:cNvPr id="1698436979" name="Slide Image Placeholder 1"/>
           <p:cNvSpPr>
             <a:spLocks noChangeAspect="1" noGrp="1" noRot="1"/>
           </p:cNvSpPr>
@@ -942,7 +856,7 @@
       </p:sp>
       <p:sp>
         <p:nvSpPr>
-          <p:cNvPr id="1337746547" name="Notes Placeholder 2"/>
+          <p:cNvPr id="881871836" name="Notes Placeholder 2"/>
           <p:cNvSpPr>
             <a:spLocks noGrp="1"/>
           </p:cNvSpPr>
@@ -964,7 +878,7 @@
       </p:sp>
       <p:sp>
         <p:nvSpPr>
-          <p:cNvPr id="742087290" name="Slide Number Placeholder 3"/>
+          <p:cNvPr id="1290538461" name="Slide Number Placeholder 3"/>
           <p:cNvSpPr>
             <a:spLocks noGrp="1"/>
           </p:cNvSpPr>
@@ -980,7 +894,7 @@
             <a:pPr>
               <a:defRPr/>
             </a:pPr>
-            <a:fld id="{CB5AAC82-58BB-DA95-5D40-1D8CE4859E05}" type="slidenum">
+            <a:fld id="{8CE5749D-D746-3467-4F72-B8DAD41FA0B9}" type="slidenum">
               <a:rPr/>
               <a:t/>
             </a:fld>
@@ -1012,7 +926,7 @@
       </p:grpSpPr>
       <p:sp>
         <p:nvSpPr>
-          <p:cNvPr id="1698436979" name="Slide Image Placeholder 1"/>
+          <p:cNvPr id="982439509" name="Slide Image Placeholder 1"/>
           <p:cNvSpPr>
             <a:spLocks noChangeAspect="1" noGrp="1" noRot="1"/>
           </p:cNvSpPr>
@@ -1024,7 +938,7 @@
       </p:sp>
       <p:sp>
         <p:nvSpPr>
-          <p:cNvPr id="881871836" name="Notes Placeholder 2"/>
+          <p:cNvPr id="411983964" name="Notes Placeholder 2"/>
           <p:cNvSpPr>
             <a:spLocks noGrp="1"/>
           </p:cNvSpPr>
@@ -1046,7 +960,7 @@
       </p:sp>
       <p:sp>
         <p:nvSpPr>
-          <p:cNvPr id="1290538461" name="Slide Number Placeholder 3"/>
+          <p:cNvPr id="1909732534" name="Slide Number Placeholder 3"/>
           <p:cNvSpPr>
             <a:spLocks noGrp="1"/>
           </p:cNvSpPr>
@@ -1062,253 +976,7 @@
             <a:pPr>
               <a:defRPr/>
             </a:pPr>
-            <a:fld id="{8CE5749D-D746-3467-4F72-B8DAD41FA0B9}" type="slidenum">
-              <a:rPr/>
-              <a:t/>
-            </a:fld>
-            <a:endParaRPr/>
-          </a:p>
-        </p:txBody>
-      </p:sp>
-    </p:spTree>
-  </p:cSld>
-</p:notes>
-</file>
-
-<file path=ppt/notesSlides/notesSlide7.xml><?xml version="1.0" encoding="utf-8"?>
-<p:notes xmlns:a="http://schemas.openxmlformats.org/drawingml/2006/main" xmlns:r="http://schemas.openxmlformats.org/officeDocument/2006/relationships" xmlns:p="http://schemas.openxmlformats.org/presentationml/2006/main" xmlns:m="http://schemas.openxmlformats.org/officeDocument/2006/math" xmlns:w="http://schemas.openxmlformats.org/wordprocessingml/2006/main">
-  <p:cSld name="">
-    <p:spTree>
-      <p:nvGrpSpPr>
-        <p:cNvPr id="1" name=""/>
-        <p:cNvGrpSpPr/>
-        <p:nvPr/>
-      </p:nvGrpSpPr>
-      <p:grpSpPr bwMode="auto">
-        <a:xfrm>
-          <a:off x="0" y="0"/>
-          <a:ext cx="0" cy="0"/>
-          <a:chOff x="0" y="0"/>
-          <a:chExt cx="0" cy="0"/>
-        </a:xfrm>
-      </p:grpSpPr>
-      <p:sp>
-        <p:nvSpPr>
-          <p:cNvPr id="982439509" name="Slide Image Placeholder 1"/>
-          <p:cNvSpPr>
-            <a:spLocks noChangeAspect="1" noGrp="1" noRot="1"/>
-          </p:cNvSpPr>
-          <p:nvPr>
-            <p:ph type="sldImg"/>
-          </p:nvPr>
-        </p:nvSpPr>
-        <p:spPr bwMode="auto"/>
-      </p:sp>
-      <p:sp>
-        <p:nvSpPr>
-          <p:cNvPr id="411983964" name="Notes Placeholder 2"/>
-          <p:cNvSpPr>
-            <a:spLocks noGrp="1"/>
-          </p:cNvSpPr>
-          <p:nvPr>
-            <p:ph type="body" idx="1"/>
-          </p:nvPr>
-        </p:nvSpPr>
-        <p:spPr bwMode="auto"/>
-        <p:txBody>
-          <a:bodyPr/>
-          <a:lstStyle/>
-          <a:p>
-            <a:pPr>
-              <a:defRPr/>
-            </a:pPr>
-            <a:endParaRPr/>
-          </a:p>
-        </p:txBody>
-      </p:sp>
-      <p:sp>
-        <p:nvSpPr>
-          <p:cNvPr id="1909732534" name="Slide Number Placeholder 3"/>
-          <p:cNvSpPr>
-            <a:spLocks noGrp="1"/>
-          </p:cNvSpPr>
-          <p:nvPr>
-            <p:ph type="sldNum" sz="quarter" idx="10"/>
-          </p:nvPr>
-        </p:nvSpPr>
-        <p:spPr bwMode="auto"/>
-        <p:txBody>
-          <a:bodyPr/>
-          <a:lstStyle/>
-          <a:p>
-            <a:pPr>
-              <a:defRPr/>
-            </a:pPr>
             <a:fld id="{079701E9-0B8F-FE32-DAE1-697CEA162A28}" type="slidenum">
-              <a:rPr/>
-              <a:t/>
-            </a:fld>
-            <a:endParaRPr/>
-          </a:p>
-        </p:txBody>
-      </p:sp>
-    </p:spTree>
-  </p:cSld>
-</p:notes>
-</file>
-
-<file path=ppt/notesSlides/notesSlide8.xml><?xml version="1.0" encoding="utf-8"?>
-<p:notes xmlns:a="http://schemas.openxmlformats.org/drawingml/2006/main" xmlns:r="http://schemas.openxmlformats.org/officeDocument/2006/relationships" xmlns:p="http://schemas.openxmlformats.org/presentationml/2006/main" xmlns:m="http://schemas.openxmlformats.org/officeDocument/2006/math" xmlns:w="http://schemas.openxmlformats.org/wordprocessingml/2006/main">
-  <p:cSld name="">
-    <p:spTree>
-      <p:nvGrpSpPr>
-        <p:cNvPr id="1" name=""/>
-        <p:cNvGrpSpPr/>
-        <p:nvPr/>
-      </p:nvGrpSpPr>
-      <p:grpSpPr bwMode="auto">
-        <a:xfrm>
-          <a:off x="0" y="0"/>
-          <a:ext cx="0" cy="0"/>
-          <a:chOff x="0" y="0"/>
-          <a:chExt cx="0" cy="0"/>
-        </a:xfrm>
-      </p:grpSpPr>
-      <p:sp>
-        <p:nvSpPr>
-          <p:cNvPr id="322133665" name="Slide Image Placeholder 1"/>
-          <p:cNvSpPr>
-            <a:spLocks noChangeAspect="1" noGrp="1" noRot="1"/>
-          </p:cNvSpPr>
-          <p:nvPr>
-            <p:ph type="sldImg"/>
-          </p:nvPr>
-        </p:nvSpPr>
-        <p:spPr bwMode="auto"/>
-      </p:sp>
-      <p:sp>
-        <p:nvSpPr>
-          <p:cNvPr id="178006936" name="Notes Placeholder 2"/>
-          <p:cNvSpPr>
-            <a:spLocks noGrp="1"/>
-          </p:cNvSpPr>
-          <p:nvPr>
-            <p:ph type="body" idx="1"/>
-          </p:nvPr>
-        </p:nvSpPr>
-        <p:spPr bwMode="auto"/>
-        <p:txBody>
-          <a:bodyPr/>
-          <a:lstStyle/>
-          <a:p>
-            <a:pPr>
-              <a:defRPr/>
-            </a:pPr>
-            <a:endParaRPr/>
-          </a:p>
-        </p:txBody>
-      </p:sp>
-      <p:sp>
-        <p:nvSpPr>
-          <p:cNvPr id="1684290143" name="Slide Number Placeholder 3"/>
-          <p:cNvSpPr>
-            <a:spLocks noGrp="1"/>
-          </p:cNvSpPr>
-          <p:nvPr>
-            <p:ph type="sldNum" sz="quarter" idx="10"/>
-          </p:nvPr>
-        </p:nvSpPr>
-        <p:spPr bwMode="auto"/>
-        <p:txBody>
-          <a:bodyPr/>
-          <a:lstStyle/>
-          <a:p>
-            <a:pPr>
-              <a:defRPr/>
-            </a:pPr>
-            <a:fld id="{2F581F3E-76B3-7453-A2E5-4E1E014751AB}" type="slidenum">
-              <a:rPr/>
-              <a:t/>
-            </a:fld>
-            <a:endParaRPr/>
-          </a:p>
-        </p:txBody>
-      </p:sp>
-    </p:spTree>
-  </p:cSld>
-</p:notes>
-</file>
-
-<file path=ppt/notesSlides/notesSlide9.xml><?xml version="1.0" encoding="utf-8"?>
-<p:notes xmlns:a="http://schemas.openxmlformats.org/drawingml/2006/main" xmlns:r="http://schemas.openxmlformats.org/officeDocument/2006/relationships" xmlns:p="http://schemas.openxmlformats.org/presentationml/2006/main" xmlns:m="http://schemas.openxmlformats.org/officeDocument/2006/math" xmlns:w="http://schemas.openxmlformats.org/wordprocessingml/2006/main">
-  <p:cSld name="">
-    <p:spTree>
-      <p:nvGrpSpPr>
-        <p:cNvPr id="1" name=""/>
-        <p:cNvGrpSpPr/>
-        <p:nvPr/>
-      </p:nvGrpSpPr>
-      <p:grpSpPr bwMode="auto">
-        <a:xfrm>
-          <a:off x="0" y="0"/>
-          <a:ext cx="0" cy="0"/>
-          <a:chOff x="0" y="0"/>
-          <a:chExt cx="0" cy="0"/>
-        </a:xfrm>
-      </p:grpSpPr>
-      <p:sp>
-        <p:nvSpPr>
-          <p:cNvPr id="726988231" name="Slide Image Placeholder 1"/>
-          <p:cNvSpPr>
-            <a:spLocks noChangeAspect="1" noGrp="1" noRot="1"/>
-          </p:cNvSpPr>
-          <p:nvPr>
-            <p:ph type="sldImg"/>
-          </p:nvPr>
-        </p:nvSpPr>
-        <p:spPr bwMode="auto"/>
-      </p:sp>
-      <p:sp>
-        <p:nvSpPr>
-          <p:cNvPr id="1024406211" name="Notes Placeholder 2"/>
-          <p:cNvSpPr>
-            <a:spLocks noGrp="1"/>
-          </p:cNvSpPr>
-          <p:nvPr>
-            <p:ph type="body" idx="1"/>
-          </p:nvPr>
-        </p:nvSpPr>
-        <p:spPr bwMode="auto"/>
-        <p:txBody>
-          <a:bodyPr/>
-          <a:lstStyle/>
-          <a:p>
-            <a:pPr>
-              <a:defRPr/>
-            </a:pPr>
-            <a:endParaRPr/>
-          </a:p>
-        </p:txBody>
-      </p:sp>
-      <p:sp>
-        <p:nvSpPr>
-          <p:cNvPr id="1704330064" name="Slide Number Placeholder 3"/>
-          <p:cNvSpPr>
-            <a:spLocks noGrp="1"/>
-          </p:cNvSpPr>
-          <p:nvPr>
-            <p:ph type="sldNum" sz="quarter" idx="10"/>
-          </p:nvPr>
-        </p:nvSpPr>
-        <p:spPr bwMode="auto"/>
-        <p:txBody>
-          <a:bodyPr/>
-          <a:lstStyle/>
-          <a:p>
-            <a:pPr>
-              <a:defRPr/>
-            </a:pPr>
-            <a:fld id="{5FAF3B4D-4C5E-ECA8-6B35-B15869A4108B}" type="slidenum">
               <a:rPr/>
               <a:t/>
             </a:fld>
@@ -4543,131 +4211,6 @@
 </p:sld>
 </file>
 
-<file path=ppt/slides/slide10.xml><?xml version="1.0" encoding="utf-8"?>
-<p:sld xmlns:a="http://schemas.openxmlformats.org/drawingml/2006/main" xmlns:r="http://schemas.openxmlformats.org/officeDocument/2006/relationships" xmlns:p="http://schemas.openxmlformats.org/presentationml/2006/main" xmlns:m="http://schemas.openxmlformats.org/officeDocument/2006/math" xmlns:w="http://schemas.openxmlformats.org/wordprocessingml/2006/main" xmlns:mc="http://schemas.openxmlformats.org/markup-compatibility/2006" showMasterPhAnim="0" showMasterSp="1" show="1">
-  <p:cSld name="">
-    <p:spTree>
-      <p:nvGrpSpPr>
-        <p:cNvPr id="1" name=""/>
-        <p:cNvGrpSpPr/>
-        <p:nvPr/>
-      </p:nvGrpSpPr>
-      <p:grpSpPr bwMode="auto">
-        <a:xfrm>
-          <a:off x="0" y="0"/>
-          <a:ext cx="0" cy="0"/>
-          <a:chOff x="0" y="0"/>
-          <a:chExt cx="0" cy="0"/>
-        </a:xfrm>
-      </p:grpSpPr>
-      <p:sp>
-        <p:nvSpPr>
-          <p:cNvPr id="250321262" name="Titre 1"/>
-          <p:cNvSpPr>
-            <a:spLocks noGrp="1"/>
-          </p:cNvSpPr>
-          <p:nvPr>
-            <p:ph type="title"/>
-          </p:nvPr>
-        </p:nvSpPr>
-        <p:spPr bwMode="auto"/>
-        <p:txBody>
-          <a:bodyPr/>
-          <a:lstStyle/>
-          <a:p>
-            <a:pPr>
-              <a:defRPr/>
-            </a:pPr>
-            <a:r>
-              <a:rPr/>
-              <a:t>Part 3 : 2</a:t>
-            </a:r>
-            <a:r>
-              <a:rPr baseline="30000"/>
-              <a:t>k</a:t>
-            </a:r>
-            <a:r>
-              <a:rPr sz="3600"/>
-              <a:t> Factorial Design</a:t>
-            </a:r>
-            <a:endParaRPr/>
-          </a:p>
-        </p:txBody>
-      </p:sp>
-      <p:sp>
-        <p:nvSpPr>
-          <p:cNvPr id="1094789569" name="Espace réservé du contenu 2"/>
-          <p:cNvSpPr>
-            <a:spLocks noGrp="1"/>
-          </p:cNvSpPr>
-          <p:nvPr>
-            <p:ph sz="half" idx="1"/>
-          </p:nvPr>
-        </p:nvSpPr>
-        <p:spPr bwMode="auto">
-          <a:xfrm>
-            <a:off x="838197" y="1825623"/>
-            <a:ext cx="5181598" cy="4351338"/>
-          </a:xfrm>
-        </p:spPr>
-        <p:txBody>
-          <a:bodyPr/>
-          <a:lstStyle/>
-          <a:p>
-            <a:pPr>
-              <a:defRPr/>
-            </a:pPr>
-            <a:r>
-              <a:rPr/>
-              <a:t>Selected Features</a:t>
-            </a:r>
-            <a:endParaRPr/>
-          </a:p>
-        </p:txBody>
-      </p:sp>
-      <p:sp>
-        <p:nvSpPr>
-          <p:cNvPr id="1498739112" name="Espace réservé du contenu 3"/>
-          <p:cNvSpPr>
-            <a:spLocks noGrp="1"/>
-          </p:cNvSpPr>
-          <p:nvPr>
-            <p:ph sz="half" idx="2"/>
-          </p:nvPr>
-        </p:nvSpPr>
-        <p:spPr bwMode="auto">
-          <a:xfrm>
-            <a:off x="6172200" y="1825623"/>
-            <a:ext cx="5181598" cy="4351338"/>
-          </a:xfrm>
-        </p:spPr>
-        <p:txBody>
-          <a:bodyPr/>
-          <a:lstStyle/>
-          <a:p>
-            <a:pPr>
-              <a:defRPr/>
-            </a:pPr>
-            <a:endParaRPr/>
-          </a:p>
-        </p:txBody>
-      </p:sp>
-    </p:spTree>
-  </p:cSld>
-  <p:clrMapOvr>
-    <a:masterClrMapping/>
-  </p:clrMapOvr>
-  <mc:AlternateContent xmlns:mc="http://schemas.openxmlformats.org/markup-compatibility/2006">
-    <mc:Choice xmlns:p159="http://schemas.microsoft.com/office/powerpoint/2015/09/main" xmlns:p14="http://schemas.microsoft.com/office/powerpoint/2010/main" Requires="p159">
-      <p:transition p14:dur="2000" advClick="1"/>
-    </mc:Choice>
-    <mc:Fallback>
-      <p:transition advClick="1"/>
-    </mc:Fallback>
-  </mc:AlternateContent>
-</p:sld>
-</file>
-
 <file path=ppt/slides/slide2.xml><?xml version="1.0" encoding="utf-8"?>
 <p:sld xmlns:a="http://schemas.openxmlformats.org/drawingml/2006/main" xmlns:r="http://schemas.openxmlformats.org/officeDocument/2006/relationships" xmlns:p="http://schemas.openxmlformats.org/presentationml/2006/main" xmlns:m="http://schemas.openxmlformats.org/officeDocument/2006/math" xmlns:w="http://schemas.openxmlformats.org/wordprocessingml/2006/main" xmlns:mc="http://schemas.openxmlformats.org/markup-compatibility/2006" showMasterPhAnim="0" showMasterSp="1" show="1">
   <p:cSld name="">
@@ -4942,6 +4485,17 @@
               <a:rPr/>
               <a:t>Missing Data ? </a:t>
             </a:r>
+            <a:r>
+              <a:rPr lang="fr-FR" sz="2400" b="0" i="0" u="none" strike="noStrike" cap="none" spc="0">
+                <a:solidFill>
+                  <a:schemeClr val="tx1"/>
+                </a:solidFill>
+                <a:latin typeface="+mn-lt"/>
+                <a:ea typeface="+mn-ea"/>
+                <a:cs typeface="+mn-cs"/>
+              </a:rPr>
+              <a:t>Type of Data ?</a:t>
+            </a:r>
             <a:endParaRPr/>
           </a:p>
           <a:p>
@@ -4978,10 +4532,12 @@
             <a:pPr lvl="1">
               <a:defRPr/>
             </a:pPr>
-            <a:r>
-              <a:rPr/>
-              <a:t>Type of Data ?</a:t>
-            </a:r>
+            <a:endParaRPr/>
+          </a:p>
+          <a:p>
+            <a:pPr lvl="2">
+              <a:defRPr/>
+            </a:pPr>
             <a:endParaRPr/>
           </a:p>
           <a:p>
@@ -5051,102 +4607,6 @@
 </file>
 
 <file path=ppt/slides/slide3.xml><?xml version="1.0" encoding="utf-8"?>
-<p:sld xmlns:a="http://schemas.openxmlformats.org/drawingml/2006/main" xmlns:r="http://schemas.openxmlformats.org/officeDocument/2006/relationships" xmlns:p="http://schemas.openxmlformats.org/presentationml/2006/main" xmlns:m="http://schemas.openxmlformats.org/officeDocument/2006/math" xmlns:w="http://schemas.openxmlformats.org/wordprocessingml/2006/main" xmlns:mc="http://schemas.openxmlformats.org/markup-compatibility/2006" showMasterPhAnim="0" showMasterSp="1" show="1">
-  <p:cSld name="">
-    <p:spTree>
-      <p:nvGrpSpPr>
-        <p:cNvPr id="1" name=""/>
-        <p:cNvGrpSpPr/>
-        <p:nvPr/>
-      </p:nvGrpSpPr>
-      <p:grpSpPr bwMode="auto">
-        <a:xfrm>
-          <a:off x="0" y="0"/>
-          <a:ext cx="0" cy="0"/>
-          <a:chOff x="0" y="0"/>
-          <a:chExt cx="0" cy="0"/>
-        </a:xfrm>
-      </p:grpSpPr>
-      <p:sp>
-        <p:nvSpPr>
-          <p:cNvPr id="1889332166" name="Titre 1"/>
-          <p:cNvSpPr>
-            <a:spLocks noGrp="1"/>
-          </p:cNvSpPr>
-          <p:nvPr>
-            <p:ph type="title"/>
-          </p:nvPr>
-        </p:nvSpPr>
-        <p:spPr bwMode="auto"/>
-        <p:txBody>
-          <a:bodyPr vertOverflow="overflow" horzOverflow="overflow" vert="horz" wrap="square" lIns="91440" tIns="45720" rIns="91440" bIns="45720" numCol="1" spcCol="0" rtlCol="0" fromWordArt="0" anchor="ctr" anchorCtr="0" forceAA="0" upright="0" compatLnSpc="0">
-            <a:normAutofit fontScale="90000" lnSpcReduction="2000"/>
-          </a:bodyPr>
-          <a:lstStyle/>
-          <a:p>
-            <a:pPr algn="ctr">
-              <a:defRPr/>
-            </a:pPr>
-            <a:r>
-              <a:rPr lang="fr-FR" sz="4400" b="0" i="0" u="none" strike="noStrike" cap="none" spc="0">
-                <a:solidFill>
-                  <a:schemeClr val="tx1"/>
-                </a:solidFill>
-                <a:latin typeface="Arial"/>
-                <a:ea typeface="Arial"/>
-                <a:cs typeface="Arial"/>
-              </a:rPr>
-              <a:t>Exploratory Analysis and Classical Statistical Inference</a:t>
-            </a:r>
-            <a:endParaRPr sz="4400"/>
-          </a:p>
-          <a:p>
-            <a:pPr>
-              <a:defRPr/>
-            </a:pPr>
-            <a:endParaRPr/>
-          </a:p>
-        </p:txBody>
-      </p:sp>
-      <p:pic>
-        <p:nvPicPr>
-          <p:cNvPr id="1044638006" name=""/>
-          <p:cNvPicPr>
-            <a:picLocks noChangeAspect="1"/>
-          </p:cNvPicPr>
-          <p:nvPr/>
-        </p:nvPicPr>
-        <p:blipFill>
-          <a:blip r:embed="rId3"/>
-          <a:stretch/>
-        </p:blipFill>
-        <p:spPr bwMode="auto">
-          <a:xfrm flipH="0" flipV="0">
-            <a:off x="669288" y="2084915"/>
-            <a:ext cx="11081067" cy="3621262"/>
-          </a:xfrm>
-          <a:prstGeom prst="rect">
-            <a:avLst/>
-          </a:prstGeom>
-        </p:spPr>
-      </p:pic>
-    </p:spTree>
-  </p:cSld>
-  <p:clrMapOvr>
-    <a:masterClrMapping/>
-  </p:clrMapOvr>
-  <mc:AlternateContent xmlns:mc="http://schemas.openxmlformats.org/markup-compatibility/2006">
-    <mc:Choice xmlns:p159="http://schemas.microsoft.com/office/powerpoint/2015/09/main" xmlns:p14="http://schemas.microsoft.com/office/powerpoint/2010/main" Requires="p159">
-      <p:transition p14:dur="2000" advClick="1"/>
-    </mc:Choice>
-    <mc:Fallback>
-      <p:transition advClick="1"/>
-    </mc:Fallback>
-  </mc:AlternateContent>
-</p:sld>
-</file>
-
-<file path=ppt/slides/slide4.xml><?xml version="1.0" encoding="utf-8"?>
 <p:sld xmlns:a="http://schemas.openxmlformats.org/drawingml/2006/main" xmlns:r="http://schemas.openxmlformats.org/officeDocument/2006/relationships" xmlns:p="http://schemas.openxmlformats.org/presentationml/2006/main" xmlns:m="http://schemas.openxmlformats.org/officeDocument/2006/math" xmlns:w="http://schemas.openxmlformats.org/wordprocessingml/2006/main" xmlns:mc="http://schemas.openxmlformats.org/markup-compatibility/2006" showMasterPhAnim="0" showMasterSp="1" show="1">
   <p:cSld name="">
     <p:spTree>
@@ -5318,7 +4778,7 @@
 </p:sld>
 </file>
 
-<file path=ppt/slides/slide5.xml><?xml version="1.0" encoding="utf-8"?>
+<file path=ppt/slides/slide4.xml><?xml version="1.0" encoding="utf-8"?>
 <p:sld xmlns:a="http://schemas.openxmlformats.org/drawingml/2006/main" xmlns:r="http://schemas.openxmlformats.org/officeDocument/2006/relationships" xmlns:p="http://schemas.openxmlformats.org/presentationml/2006/main" xmlns:m="http://schemas.openxmlformats.org/officeDocument/2006/math" xmlns:w="http://schemas.openxmlformats.org/wordprocessingml/2006/main" xmlns:mc="http://schemas.openxmlformats.org/markup-compatibility/2006" showMasterPhAnim="0" showMasterSp="1" show="1">
   <p:cSld name="">
     <p:spTree>
@@ -5428,7 +4888,7 @@
 </p:sld>
 </file>
 
-<file path=ppt/slides/slide6.xml><?xml version="1.0" encoding="utf-8"?>
+<file path=ppt/slides/slide5.xml><?xml version="1.0" encoding="utf-8"?>
 <p:sld xmlns:a="http://schemas.openxmlformats.org/drawingml/2006/main" xmlns:r="http://schemas.openxmlformats.org/officeDocument/2006/relationships" xmlns:p="http://schemas.openxmlformats.org/presentationml/2006/main" xmlns:m="http://schemas.openxmlformats.org/officeDocument/2006/math" xmlns:w="http://schemas.openxmlformats.org/wordprocessingml/2006/main" xmlns:mc="http://schemas.openxmlformats.org/markup-compatibility/2006" showMasterPhAnim="0" showMasterSp="1" show="1">
   <p:cSld name="">
     <p:spTree>
@@ -5653,7 +5113,7 @@
 </p:sld>
 </file>
 
-<file path=ppt/slides/slide7.xml><?xml version="1.0" encoding="utf-8"?>
+<file path=ppt/slides/slide6.xml><?xml version="1.0" encoding="utf-8"?>
 <p:sld xmlns:a="http://schemas.openxmlformats.org/drawingml/2006/main" xmlns:r="http://schemas.openxmlformats.org/officeDocument/2006/relationships" xmlns:p="http://schemas.openxmlformats.org/presentationml/2006/main" xmlns:m="http://schemas.openxmlformats.org/officeDocument/2006/math" xmlns:w="http://schemas.openxmlformats.org/wordprocessingml/2006/main" xmlns:mc="http://schemas.openxmlformats.org/markup-compatibility/2006" showMasterPhAnim="0" showMasterSp="1" show="1">
   <p:cSld name="">
     <p:spTree>
@@ -5703,306 +5163,28 @@
           </a:p>
         </p:txBody>
       </p:sp>
-      <p:sp>
-        <p:nvSpPr>
-          <p:cNvPr id="118347481" name="Espace réservé du contenu 2"/>
-          <p:cNvSpPr>
-            <a:spLocks noGrp="1"/>
-          </p:cNvSpPr>
-          <p:nvPr>
-            <p:ph sz="half" idx="1"/>
-          </p:nvPr>
-        </p:nvSpPr>
+      <p:pic>
+        <p:nvPicPr>
+          <p:cNvPr id="1928476549" name=""/>
+          <p:cNvPicPr>
+            <a:picLocks noChangeAspect="1"/>
+          </p:cNvPicPr>
+          <p:nvPr/>
+        </p:nvPicPr>
+        <p:blipFill>
+          <a:blip r:embed="rId3"/>
+          <a:stretch/>
+        </p:blipFill>
         <p:spPr bwMode="auto">
-          <a:xfrm>
-            <a:off x="838197" y="1825623"/>
-            <a:ext cx="5181598" cy="4351338"/>
+          <a:xfrm flipH="0" flipV="0">
+            <a:off x="2482853" y="1763957"/>
+            <a:ext cx="5410360" cy="4530843"/>
           </a:xfrm>
+          <a:prstGeom prst="rect">
+            <a:avLst/>
+          </a:prstGeom>
         </p:spPr>
-        <p:txBody>
-          <a:bodyPr/>
-          <a:lstStyle/>
-          <a:p>
-            <a:pPr>
-              <a:defRPr/>
-            </a:pPr>
-            <a:endParaRPr/>
-          </a:p>
-        </p:txBody>
-      </p:sp>
-      <p:sp>
-        <p:nvSpPr>
-          <p:cNvPr id="1320543693" name="Espace réservé du contenu 3"/>
-          <p:cNvSpPr>
-            <a:spLocks noGrp="1"/>
-          </p:cNvSpPr>
-          <p:nvPr>
-            <p:ph sz="half" idx="2"/>
-          </p:nvPr>
-        </p:nvSpPr>
-        <p:spPr bwMode="auto">
-          <a:xfrm>
-            <a:off x="6172200" y="1825623"/>
-            <a:ext cx="5181598" cy="4351338"/>
-          </a:xfrm>
-        </p:spPr>
-        <p:txBody>
-          <a:bodyPr/>
-          <a:lstStyle/>
-          <a:p>
-            <a:pPr>
-              <a:defRPr/>
-            </a:pPr>
-            <a:endParaRPr/>
-          </a:p>
-        </p:txBody>
-      </p:sp>
-    </p:spTree>
-  </p:cSld>
-  <p:clrMapOvr>
-    <a:masterClrMapping/>
-  </p:clrMapOvr>
-  <mc:AlternateContent xmlns:mc="http://schemas.openxmlformats.org/markup-compatibility/2006">
-    <mc:Choice xmlns:p159="http://schemas.microsoft.com/office/powerpoint/2015/09/main" xmlns:p14="http://schemas.microsoft.com/office/powerpoint/2010/main" Requires="p159">
-      <p:transition p14:dur="2000" advClick="1"/>
-    </mc:Choice>
-    <mc:Fallback>
-      <p:transition advClick="1"/>
-    </mc:Fallback>
-  </mc:AlternateContent>
-</p:sld>
-</file>
-
-<file path=ppt/slides/slide8.xml><?xml version="1.0" encoding="utf-8"?>
-<p:sld xmlns:a="http://schemas.openxmlformats.org/drawingml/2006/main" xmlns:r="http://schemas.openxmlformats.org/officeDocument/2006/relationships" xmlns:p="http://schemas.openxmlformats.org/presentationml/2006/main" xmlns:m="http://schemas.openxmlformats.org/officeDocument/2006/math" xmlns:w="http://schemas.openxmlformats.org/wordprocessingml/2006/main" xmlns:mc="http://schemas.openxmlformats.org/markup-compatibility/2006" showMasterPhAnim="0" showMasterSp="1" show="1">
-  <p:cSld name="">
-    <p:spTree>
-      <p:nvGrpSpPr>
-        <p:cNvPr id="1" name=""/>
-        <p:cNvGrpSpPr/>
-        <p:nvPr/>
-      </p:nvGrpSpPr>
-      <p:grpSpPr bwMode="auto">
-        <a:xfrm>
-          <a:off x="0" y="0"/>
-          <a:ext cx="0" cy="0"/>
-          <a:chOff x="0" y="0"/>
-          <a:chExt cx="0" cy="0"/>
-        </a:xfrm>
-      </p:grpSpPr>
-      <p:sp>
-        <p:nvSpPr>
-          <p:cNvPr id="932837120" name="Titre 1"/>
-          <p:cNvSpPr>
-            <a:spLocks noGrp="1"/>
-          </p:cNvSpPr>
-          <p:nvPr>
-            <p:ph type="title"/>
-          </p:nvPr>
-        </p:nvSpPr>
-        <p:spPr bwMode="auto"/>
-        <p:txBody>
-          <a:bodyPr/>
-          <a:lstStyle/>
-          <a:p>
-            <a:pPr>
-              <a:defRPr/>
-            </a:pPr>
-            <a:r>
-              <a:rPr/>
-              <a:t>Part 2 : ANOVA – significant features</a:t>
-            </a:r>
-            <a:endParaRPr/>
-          </a:p>
-        </p:txBody>
-      </p:sp>
-      <p:sp>
-        <p:nvSpPr>
-          <p:cNvPr id="1843941217" name="Espace réservé du contenu 2"/>
-          <p:cNvSpPr>
-            <a:spLocks noGrp="1"/>
-          </p:cNvSpPr>
-          <p:nvPr>
-            <p:ph sz="half" idx="1"/>
-          </p:nvPr>
-        </p:nvSpPr>
-        <p:spPr bwMode="auto">
-          <a:xfrm>
-            <a:off x="838197" y="1825623"/>
-            <a:ext cx="5181598" cy="4351338"/>
-          </a:xfrm>
-        </p:spPr>
-        <p:txBody>
-          <a:bodyPr/>
-          <a:lstStyle/>
-          <a:p>
-            <a:pPr>
-              <a:defRPr/>
-            </a:pPr>
-            <a:r>
-              <a:rPr/>
-              <a:t>Tukey HSD</a:t>
-            </a:r>
-            <a:endParaRPr/>
-          </a:p>
-        </p:txBody>
-      </p:sp>
-      <p:sp>
-        <p:nvSpPr>
-          <p:cNvPr id="1262002431" name="Espace réservé du contenu 3"/>
-          <p:cNvSpPr>
-            <a:spLocks noGrp="1"/>
-          </p:cNvSpPr>
-          <p:nvPr>
-            <p:ph sz="half" idx="2"/>
-          </p:nvPr>
-        </p:nvSpPr>
-        <p:spPr bwMode="auto">
-          <a:xfrm>
-            <a:off x="6172200" y="1825623"/>
-            <a:ext cx="5181598" cy="4351338"/>
-          </a:xfrm>
-        </p:spPr>
-        <p:txBody>
-          <a:bodyPr/>
-          <a:lstStyle/>
-          <a:p>
-            <a:pPr>
-              <a:defRPr/>
-            </a:pPr>
-            <a:r>
-              <a:rPr/>
-              <a:t>Significant features</a:t>
-            </a:r>
-            <a:endParaRPr/>
-          </a:p>
-        </p:txBody>
-      </p:sp>
-    </p:spTree>
-  </p:cSld>
-  <p:clrMapOvr>
-    <a:masterClrMapping/>
-  </p:clrMapOvr>
-  <mc:AlternateContent xmlns:mc="http://schemas.openxmlformats.org/markup-compatibility/2006">
-    <mc:Choice xmlns:p159="http://schemas.microsoft.com/office/powerpoint/2015/09/main" xmlns:p14="http://schemas.microsoft.com/office/powerpoint/2010/main" Requires="p159">
-      <p:transition p14:dur="2000" advClick="1"/>
-    </mc:Choice>
-    <mc:Fallback>
-      <p:transition advClick="1"/>
-    </mc:Fallback>
-  </mc:AlternateContent>
-</p:sld>
-</file>
-
-<file path=ppt/slides/slide9.xml><?xml version="1.0" encoding="utf-8"?>
-<p:sld xmlns:a="http://schemas.openxmlformats.org/drawingml/2006/main" xmlns:r="http://schemas.openxmlformats.org/officeDocument/2006/relationships" xmlns:p="http://schemas.openxmlformats.org/presentationml/2006/main" xmlns:m="http://schemas.openxmlformats.org/officeDocument/2006/math" xmlns:w="http://schemas.openxmlformats.org/wordprocessingml/2006/main" xmlns:mc="http://schemas.openxmlformats.org/markup-compatibility/2006" showMasterPhAnim="0" showMasterSp="1" show="1">
-  <p:cSld name="">
-    <p:spTree>
-      <p:nvGrpSpPr>
-        <p:cNvPr id="1" name=""/>
-        <p:cNvGrpSpPr/>
-        <p:nvPr/>
-      </p:nvGrpSpPr>
-      <p:grpSpPr bwMode="auto">
-        <a:xfrm>
-          <a:off x="0" y="0"/>
-          <a:ext cx="0" cy="0"/>
-          <a:chOff x="0" y="0"/>
-          <a:chExt cx="0" cy="0"/>
-        </a:xfrm>
-      </p:grpSpPr>
-      <p:sp>
-        <p:nvSpPr>
-          <p:cNvPr id="1340960394" name="Titre 1"/>
-          <p:cNvSpPr>
-            <a:spLocks noGrp="1"/>
-          </p:cNvSpPr>
-          <p:nvPr>
-            <p:ph type="title"/>
-          </p:nvPr>
-        </p:nvSpPr>
-        <p:spPr bwMode="auto"/>
-        <p:txBody>
-          <a:bodyPr/>
-          <a:lstStyle/>
-          <a:p>
-            <a:pPr>
-              <a:defRPr/>
-            </a:pPr>
-            <a:r>
-              <a:rPr/>
-              <a:t>Part 3 : 2</a:t>
-            </a:r>
-            <a:r>
-              <a:rPr baseline="30000"/>
-              <a:t>k</a:t>
-            </a:r>
-            <a:r>
-              <a:rPr sz="3600"/>
-              <a:t> Factorial Design</a:t>
-            </a:r>
-            <a:endParaRPr/>
-          </a:p>
-        </p:txBody>
-      </p:sp>
-      <p:sp>
-        <p:nvSpPr>
-          <p:cNvPr id="1287313540" name="Espace réservé du contenu 2"/>
-          <p:cNvSpPr>
-            <a:spLocks noGrp="1"/>
-          </p:cNvSpPr>
-          <p:nvPr>
-            <p:ph sz="half" idx="1"/>
-          </p:nvPr>
-        </p:nvSpPr>
-        <p:spPr bwMode="auto">
-          <a:xfrm>
-            <a:off x="838197" y="1825623"/>
-            <a:ext cx="5181598" cy="4351338"/>
-          </a:xfrm>
-        </p:spPr>
-        <p:txBody>
-          <a:bodyPr/>
-          <a:lstStyle/>
-          <a:p>
-            <a:pPr>
-              <a:defRPr/>
-            </a:pPr>
-            <a:r>
-              <a:rPr/>
-              <a:t>Selected Features</a:t>
-            </a:r>
-            <a:endParaRPr/>
-          </a:p>
-        </p:txBody>
-      </p:sp>
-      <p:sp>
-        <p:nvSpPr>
-          <p:cNvPr id="758637506" name="Espace réservé du contenu 3"/>
-          <p:cNvSpPr>
-            <a:spLocks noGrp="1"/>
-          </p:cNvSpPr>
-          <p:nvPr>
-            <p:ph sz="half" idx="2"/>
-          </p:nvPr>
-        </p:nvSpPr>
-        <p:spPr bwMode="auto">
-          <a:xfrm>
-            <a:off x="6172200" y="1825623"/>
-            <a:ext cx="5181598" cy="4351338"/>
-          </a:xfrm>
-        </p:spPr>
-        <p:txBody>
-          <a:bodyPr/>
-          <a:lstStyle/>
-          <a:p>
-            <a:pPr>
-              <a:defRPr/>
-            </a:pPr>
-            <a:endParaRPr/>
-          </a:p>
-        </p:txBody>
-      </p:sp>
+      </p:pic>
     </p:spTree>
   </p:cSld>
   <p:clrMapOvr>

</xml_diff>